<commit_message>
Clarify spirituality study and realization deck
</commit_message>
<xml_diff>
--- a/Studies/Spiritual-Practice-And-Realization/Spiritual-Practice-And-Realization-Madhyasth-Darshan.pptx
+++ b/Studies/Spiritual-Practice-And-Realization/Spiritual-Practice-And-Realization-Madhyasth-Darshan.pptx
@@ -607,23 +607,31 @@
         </p:nvSpPr>
         <p:spPr/>
         <p:txBody>
-          <a:bodyPr/>
-          <a:lstStyle/>
-          <a:p>
-            <a:r>
-              <a:t>Because the darshan refuses to let an inner state serve as its own credential, it needs public marks, and it names three kinds of evidence: realisation, behaviour, and experiment. The awakened human, not scripture or instrument, is the basis of evidence.</a:t>
-            </a:r>
-          </a:p>
-          <a:p/>
-          <a:p>
+          <a:bodyPr xmlns:a="http://schemas.openxmlformats.org/drawingml/2006/main"/>
+          <a:lstStyle xmlns:a="http://schemas.openxmlformats.org/drawingml/2006/main"/>
+          <a:p xmlns:a="http://schemas.openxmlformats.org/drawingml/2006/main">
+            <a:r>
+              <a:t>The darshan names realisation, behaviour, and experiment as evidence. Realisation itself is the ultimate evidence, and understanding manifests in resolution, work, behaviour, and awakened tradition (MVD p. 12). A person's report of an inner experience must therefore be distinguished from accomplished realisation and its expression in living. The awakened human is the basis of evidence (SB p. 5).</a:t>
+            </a:r>
+          </a:p>
+          <a:p xmlns:a="http://schemas.openxmlformats.org/drawingml/2006/main">
+            <a:r>
+              <a:t/>
+            </a:r>
+          </a:p>
+          <a:p xmlns:a="http://schemas.openxmlformats.org/drawingml/2006/main">
             <a:r>
               <a:t>Understanding must be conveyable: the proof of comprehension is the ability to convey it to others. Conduct must change: realisation shows as justice, dharma, and truth in behaviour, thought, and realisation together, as the absence of mistakes and crimes, and as the ability to provide justice, which is the evidence of liberation from bondage. Work with nature must succeed, since experimentation is continued until natural abundance is made useful. And the change must be reproducible in tradition: an awakened human evidences awakening by paving the path for the deluded.</a:t>
             </a:r>
           </a:p>
-          <a:p/>
-          <a:p>
-            <a:r>
-              <a:t>Behind these marks stands the criterion of truth: what is uniformly realised everywhere, the same in, by, and for all human beings. In the darshan's architecture, evidence is the fourth stage of realisation itself rather than a test applied from outside.</a:t>
+          <a:p xmlns:a="http://schemas.openxmlformats.org/drawingml/2006/main">
+            <a:r>
+              <a:t/>
+            </a:r>
+          </a:p>
+          <a:p xmlns:a="http://schemas.openxmlformats.org/drawingml/2006/main">
+            <a:r>
+              <a:t>Behind these marks stands the criterion of truth: what is uniformly realised everywhere, the same in, by, and for all human beings. Realisation and its expression in living belong together in the account of evidence.</a:t>
             </a:r>
           </a:p>
         </p:txBody>
@@ -689,15 +697,19 @@
         </p:nvSpPr>
         <p:spPr/>
         <p:txBody>
-          <a:bodyPr/>
-          <a:lstStyle/>
-          <a:p>
-            <a:r>
-              <a:t>Part Two turns to the negative finding that shapes the whole account. The darshan's founder, Shri A. Nagraj, was told that samadhi was the only way to know the unknown. He attained it, and reported that no knowing occurred in it.</a:t>
-            </a:r>
-          </a:p>
-          <a:p/>
-          <a:p>
+          <a:bodyPr xmlns:a="http://schemas.openxmlformats.org/drawingml/2006/main"/>
+          <a:lstStyle xmlns:a="http://schemas.openxmlformats.org/drawingml/2006/main"/>
+          <a:p xmlns:a="http://schemas.openxmlformats.org/drawingml/2006/main">
+            <a:r>
+              <a:t>Part Two turns to the negative finding that shapes the whole account. The darshan's founder, Shri A. Nagraj, was told that samadhi was the only way to know the unknown. He attained it and reported that the event of knowing the unknown did not occur. His foundational questions remained unanswered (MVD p. 7; JV pp. 12–13).</a:t>
+            </a:r>
+          </a:p>
+          <a:p xmlns:a="http://schemas.openxmlformats.org/drawingml/2006/main">
+            <a:r>
+              <a:t/>
+            </a:r>
+          </a:p>
+          <a:p xmlns:a="http://schemas.openxmlformats.org/drawingml/2006/main">
             <a:r>
               <a:t>What he found productive instead was a samyama of his own design, which led to realisation of coexistence. This part also names what practice actually removes: mystery and delusion, and the three bondages of hope, thought, and desire.</a:t>
             </a:r>
@@ -765,27 +777,39 @@
         </p:nvSpPr>
         <p:spPr/>
         <p:txBody>
-          <a:bodyPr/>
-          <a:lstStyle/>
-          <a:p>
+          <a:bodyPr xmlns:a="http://schemas.openxmlformats.org/drawingml/2006/main"/>
+          <a:lstStyle xmlns:a="http://schemas.openxmlformats.org/drawingml/2006/main"/>
+          <a:p xmlns:a="http://schemas.openxmlformats.org/drawingml/2006/main">
             <a:r>
               <a:t>The account of practice begins with a report in the first person. Nagraj was assured by the scholars and sages of his time that the only way to know the unknown is samadhi. He accepted this, went to Amarkantak, and practised from 1950, following the traditional method of upasana, with maturity in the 1960s.</a:t>
             </a:r>
           </a:p>
-          <a:p/>
-          <a:p>
+          <a:p xmlns:a="http://schemas.openxmlformats.org/drawingml/2006/main">
+            <a:r>
+              <a:t/>
+            </a:r>
+          </a:p>
+          <a:p xmlns:a="http://schemas.openxmlformats.org/drawingml/2006/main">
             <a:r>
               <a:t>In 1970 he accepted that he had attained samadhi. Hope, thought, and desire fell silent, and the event of knowing the unknown did not occur. The state recurred for twelve to eighteen hours a day, and it answered none of his questions.</a:t>
             </a:r>
           </a:p>
-          <a:p/>
-          <a:p>
-            <a:r>
-              <a:t>Two claims are made here. The first is that no knowing occurs in the absorbed state. The second is that because there is nothing in it to describe, it cannot serve as evidence of anything, including of itself.</a:t>
-            </a:r>
-          </a:p>
-          <a:p/>
-          <a:p>
+          <a:p xmlns:a="http://schemas.openxmlformats.org/drawingml/2006/main">
+            <a:r>
+              <a:t/>
+            </a:r>
+          </a:p>
+          <a:p xmlns:a="http://schemas.openxmlformats.org/drawingml/2006/main">
+            <a:r>
+              <a:t>Nagraj reports that the unknown remained unknown: his foundational questions were unanswered. He also asks how he could present evidence for a state in which he found nothing to describe (MVD p. 7; JV pp. 12–13). This specifies the limits he encountered in that practice.</a:t>
+            </a:r>
+          </a:p>
+          <a:p xmlns:a="http://schemas.openxmlformats.org/drawingml/2006/main">
+            <a:r>
+              <a:t/>
+            </a:r>
+          </a:p>
+          <a:p xmlns:a="http://schemas.openxmlformats.org/drawingml/2006/main">
             <a:r>
               <a:t>The state is not nothing. It yields self-limited happiness, free of fear, temptation, and the pain of lack. But no programme of living arises in it; while pursuing it the seeker cannot take part in family, society, or the system of living; and the person's usefulness becomes zero.</a:t>
             </a:r>
@@ -935,27 +959,39 @@
         </p:nvSpPr>
         <p:spPr/>
         <p:txBody>
-          <a:bodyPr/>
-          <a:lstStyle/>
-          <a:p>
-            <a:r>
-              <a:t>The darshan names its target mystery, and it defines mystery as a deficiency of understanding rather than a property of reality: not revealing understanding, not being able to, or not being able to attain it.</a:t>
-            </a:r>
-          </a:p>
-          <a:p/>
-          <a:p>
+          <a:bodyPr xmlns:a="http://schemas.openxmlformats.org/drawingml/2006/main"/>
+          <a:lstStyle xmlns:a="http://schemas.openxmlformats.org/drawingml/2006/main"/>
+          <a:p xmlns:a="http://schemas.openxmlformats.org/drawingml/2006/main">
+            <a:r>
+              <a:t>Mystery concerns failing to attain or communicate understanding: not revealing it, being unable to reveal it, or being unable to attain it (MVD p. 273). The first two can concern someone who understands but does not communicate. Reality itself remains knowable.</a:t>
+            </a:r>
+          </a:p>
+          <a:p xmlns:a="http://schemas.openxmlformats.org/drawingml/2006/main">
+            <a:r>
+              <a:t/>
+            </a:r>
+          </a:p>
+          <a:p xmlns:a="http://schemas.openxmlformats.org/drawingml/2006/main">
             <a:r>
               <a:t>Beneath mystery lies delusion, belief different from reality, and its root is the assumption that the body is jeevan. Delusion is at the root of all unhappiness. It shows as excess, deficiency, and omission in visualisation, and as over-, under-, and mis-evaluation in judgement.</a:t>
             </a:r>
           </a:p>
-          <a:p/>
-          <a:p>
+          <a:p xmlns:a="http://schemas.openxmlformats.org/drawingml/2006/main">
+            <a:r>
+              <a:t/>
+            </a:r>
+          </a:p>
+          <a:p xmlns:a="http://schemas.openxmlformats.org/drawingml/2006/main">
             <a:r>
               <a:t>What is bound, what binds, and what is freed is jeevan itself, and bondage takes three forms: bondage of hope, directed at sensory gratification; bondage of thought, which takes one's own thoughts to be superior; and bondage of desire, which takes the maximisation of physical creation to be superior.</a:t>
             </a:r>
           </a:p>
-          <a:p/>
-          <a:p>
+          <a:p xmlns:a="http://schemas.openxmlformats.org/drawingml/2006/main">
+            <a:r>
+              <a:t/>
+            </a:r>
+          </a:p>
+          <a:p xmlns:a="http://schemas.openxmlformats.org/drawingml/2006/main">
             <a:r>
               <a:t>The darshan's proposal is liberation from delusion. Freedom from the bondage of delusion is moksha, and it is the evidence of awakening.</a:t>
             </a:r>
@@ -1023,17 +1059,21 @@
         </p:nvSpPr>
         <p:spPr/>
         <p:txBody>
-          <a:bodyPr/>
-          <a:lstStyle/>
-          <a:p>
+          <a:bodyPr xmlns:a="http://schemas.openxmlformats.org/drawingml/2006/main"/>
+          <a:lstStyle xmlns:a="http://schemas.openxmlformats.org/drawingml/2006/main"/>
+          <a:p xmlns:a="http://schemas.openxmlformats.org/drawingml/2006/main">
             <a:r>
               <a:t>Part Three is the practical core. It begins with jeevan: its ten activities, of which only four and a half are effective in delusion, and the 122 conducts in which awakening becomes evident.</a:t>
             </a:r>
           </a:p>
-          <a:p/>
-          <a:p>
-            <a:r>
-              <a:t>It then shows what practice does to those activities: study as the practice itself, the two paths and their programmes, upasana as the refining of the fundamental tendencies, concentration and inward regulation, the conditions under which reflection succeeds, the marks of progress, and the preconditions and the teacher. It ends with what results: liberation from delusion.</a:t>
+          <a:p xmlns:a="http://schemas.openxmlformats.org/drawingml/2006/main">
+            <a:r>
+              <a:t/>
+            </a:r>
+          </a:p>
+          <a:p xmlns:a="http://schemas.openxmlformats.org/drawingml/2006/main">
+            <a:r>
+              <a:t>It then shows what practice does to those activities: study as the practice itself, the two paths and their programmes, upasana as the refining of the fundamental tendencies, concentration and inward regulation, the conditions under which reflection succeeds, the marks of progress, and the preconditions and the teacher. It ends with what results: liberation from delusion. The darshan names realisation a state, kaivalya or tadatmya (MVD pp. 317–318). Practice develops understanding and the effectiveness of activities already present in jeevan.</a:t>
             </a:r>
           </a:p>
         </p:txBody>
@@ -1181,23 +1221,31 @@
         </p:nvSpPr>
         <p:spPr/>
         <p:txBody>
-          <a:bodyPr/>
-          <a:lstStyle/>
-          <a:p>
+          <a:bodyPr xmlns:a="http://schemas.openxmlformats.org/drawingml/2006/main"/>
+          <a:lstStyle xmlns:a="http://schemas.openxmlformats.org/drawingml/2006/main"/>
+          <a:p xmlns:a="http://schemas.openxmlformats.org/drawingml/2006/main">
             <a:r>
               <a:t>The ten are the generic activities. In awakening their detailed content becomes evident as 122 activities: two in atma, four in buddhi, sixteen in chitta, thirty-six in vritti, and sixty-four in mun. Each person can demonstrate all of them.</a:t>
             </a:r>
           </a:p>
-          <a:p/>
-          <a:p>
-            <a:r>
-              <a:t>They are tabulated as sixty-one pairs of a reflective and a projective activity, and each is defined. They include most of what the contemplative and devotional traditions treat as spiritual attainments: in atma, realisation in existence and the authenticity of ultimate bliss; in buddhi, bliss and definiteness, existence and fearlessness; in chitta, love and non-otherness, reverence and devoutness; in vritti, peace and kindness, gratitude and humility, truth and dharma; in mun, devotion and immersion, care and generosity, affection and dedication.</a:t>
-            </a:r>
-          </a:p>
-          <a:p/>
-          <a:p>
-            <a:r>
-              <a:t>So bliss, love, reverence, devotion, forgiveness, gratitude, and restraint are not states to be attained in withdrawal. They are named conducts of awakened jeevan, and many of them are directed to other people. This is where practice becomes specific: it aims at making effective activities that jeevan already has. Their systematic study is the subject of a separate treatise, Manav Sanchetnavadi Manovigyan.</a:t>
+          <a:p xmlns:a="http://schemas.openxmlformats.org/drawingml/2006/main">
+            <a:r>
+              <a:t/>
+            </a:r>
+          </a:p>
+          <a:p xmlns:a="http://schemas.openxmlformats.org/drawingml/2006/main">
+            <a:r>
+              <a:t>They are tabulated as sixty-one pairs of a reflective and a projective activity, and each is defined. They include most of what the contemplative and devotional traditions treat as spiritual attainments: in atma, realisation in existence and the authenticity of ultimate bliss; in buddhi, bliss and dhee, existence and fearlessness; in chitta, love and non-otherness, reverence and devoutness; in vritti, peace and kindness, gratitude and humility, truth and dharma; in mun, devotion and immersion, care and generosity, affection and dedication.</a:t>
+            </a:r>
+          </a:p>
+          <a:p xmlns:a="http://schemas.openxmlformats.org/drawingml/2006/main">
+            <a:r>
+              <a:t/>
+            </a:r>
+          </a:p>
+          <a:p xmlns:a="http://schemas.openxmlformats.org/drawingml/2006/main">
+            <a:r>
+              <a:t>Dhee includes definiteness and readiness to express or project celebration (MVD pp. 324, 328). Bliss, love, reverence, devotion, forgiveness, gratitude, and restraint name conducts of awakened jeevan, and many of them are directed to other people. This is where practice becomes specific: it aims at making effective activities that jeevan already has. Their systematic study is the subject of a separate treatise, Manav Sanchetnavadi Manovigyan.</a:t>
             </a:r>
           </a:p>
         </p:txBody>
@@ -1263,21 +1311,29 @@
         </p:nvSpPr>
         <p:spPr/>
         <p:txBody>
-          <a:bodyPr/>
-          <a:lstStyle/>
-          <a:p>
+          <a:bodyPr xmlns:a="http://schemas.openxmlformats.org/drawingml/2006/main"/>
+          <a:lstStyle xmlns:a="http://schemas.openxmlformats.org/drawingml/2006/main"/>
+          <a:p xmlns:a="http://schemas.openxmlformats.org/drawingml/2006/main">
             <a:r>
               <a:t>Practice has a precisely located target. Under delusion, hope in mun is based on sensation, thought in vritti follows that hope, desire in chitta follows that thought, and buddhi, turned away from atma, supports deluded visualisation and desire.</a:t>
             </a:r>
           </a:p>
-          <a:p/>
-          <a:p>
-            <a:r>
-              <a:t>In awakening the direction reverses. The enlightenment of buddhi accords with atma's realisation in existence, desire in chitta accords with the enlightenment of buddhi, thought in vritti with chitta, and hope in mun with vritti. The resulting reflection and projection form the awakened jeevan cycle. So practice is the repair of a circuit, not the accumulation of states.</a:t>
-            </a:r>
-          </a:p>
-          <a:p/>
-          <a:p>
+          <a:p xmlns:a="http://schemas.openxmlformats.org/drawingml/2006/main">
+            <a:r>
+              <a:t/>
+            </a:r>
+          </a:p>
+          <a:p xmlns:a="http://schemas.openxmlformats.org/drawingml/2006/main">
+            <a:r>
+              <a:t>In awakening the direction reverses. The enlightenment of buddhi accords with atma's realisation in existence, desire in chitta accords with the enlightenment of buddhi, thought in vritti with chitta, and hope in mun with vritti. The resulting reflection and projection form the awakened jeevan cycle. Practice thus reorients the faculties in understanding and effective expression. Jeevan is constitutionally complete and its ten activities continue in delusion and awakening (JV pp. 73–74). The diagram represents functional dependence, rather than damage or repair to its constitution.</a:t>
+            </a:r>
+          </a:p>
+          <a:p xmlns:a="http://schemas.openxmlformats.org/drawingml/2006/main">
+            <a:r>
+              <a:t/>
+            </a:r>
+          </a:p>
+          <a:p xmlns:a="http://schemas.openxmlformats.org/drawingml/2006/main">
             <a:r>
               <a:t>Awakening begins with the strength of contemplation, whereas the bondage of delusion runs on the powers of hope, thought, and desire. Study supplies contemplation with its content: as definitive understanding grows, justice, dharma, and truth become active in the deliberation of vritti, are directly recognised in chitta, enlightened and accepted in buddhi, and realised in atma.</a:t>
             </a:r>
@@ -1345,29 +1401,51 @@
         </p:nvSpPr>
         <p:spPr/>
         <p:txBody>
-          <a:bodyPr/>
-          <a:lstStyle/>
-          <a:p>
+          <a:bodyPr xmlns:a="http://schemas.openxmlformats.org/drawingml/2006/main"/>
+          <a:lstStyle xmlns:a="http://schemas.openxmlformats.org/drawingml/2006/main"/>
+          <a:p xmlns:a="http://schemas.openxmlformats.org/drawingml/2006/main">
             <a:r>
               <a:t>The positive method is study, and the darshan states it in the vocabulary of worship: study itself is worship, and the authentic human is the teacher in whose proximity study takes place. Through study one comes into absolute-resonance and absolute-accordance with understanding.</a:t>
             </a:r>
           </a:p>
-          <a:p/>
-          <a:p>
+          <a:p xmlns:a="http://schemas.openxmlformats.org/drawingml/2006/main">
+            <a:r>
+              <a:t/>
+            </a:r>
+          </a:p>
+          <a:p xmlns:a="http://schemas.openxmlformats.org/drawingml/2006/main">
             <a:r>
               <a:t>Study is defined by what it discriminates: understanding the difference between the laws necessary and unnecessary for humaneness is study, and implementing the necessary ones is evidence and accomplishment. The journey to realisation begins with methodical study, whose field is definitive understanding.</a:t>
             </a:r>
           </a:p>
-          <a:p/>
-          <a:p>
+          <a:p xmlns:a="http://schemas.openxmlformats.org/drawingml/2006/main">
+            <a:r>
+              <a:t/>
+            </a:r>
+          </a:p>
+          <a:p xmlns:a="http://schemas.openxmlformats.org/drawingml/2006/main">
             <a:r>
               <a:t>Study proceeds by two means that correct each other, inquiry while studying and study while inquiring, and each person examines what is presented with their own imagination and freedom of action and accepts or rejects it. Instruction by sermon carries a possibility of delusion; a command remains information until its intent is understood in logic and behaviour.</a:t>
             </a:r>
           </a:p>
-          <a:p/>
-          <a:p>
-            <a:r>
-              <a:t>Dedication carries study to realisation. The formula for belief is short: believe what is known; know what is believed. In the 2010 recorded session Nagraj calls sakshatkar, direct recognition, the success of study.</a:t>
+          <a:p xmlns:a="http://schemas.openxmlformats.org/drawingml/2006/main">
+            <a:r>
+              <a:t/>
+            </a:r>
+          </a:p>
+          <a:p xmlns:a="http://schemas.openxmlformats.org/drawingml/2006/main">
+            <a:r>
+              <a:t>Dedication carries study to realisation. The formula for belief is short: believe what is known; know what is believed. The affirmation of coexistence through study includes direct recognition in chitta and understanding in buddhi (MVD p. 126).</a:t>
+            </a:r>
+          </a:p>
+          <a:p xmlns:a="http://schemas.openxmlformats.org/drawingml/2006/main">
+            <a:r>
+              <a:t/>
+            </a:r>
+          </a:p>
+          <a:p xmlns:a="http://schemas.openxmlformats.org/drawingml/2006/main">
+            <a:r>
+              <a:t>Successful study also depends on mutually complementary support from teachers, guardians, teaching, and educational content and procedure (MVD p. 270). The learner's participation develops within this shared responsibility.</a:t>
             </a:r>
           </a:p>
         </p:txBody>
@@ -1515,23 +1593,31 @@
         </p:nvSpPr>
         <p:spPr/>
         <p:txBody>
-          <a:bodyPr/>
-          <a:lstStyle/>
-          <a:p>
+          <a:bodyPr xmlns:a="http://schemas.openxmlformats.org/drawingml/2006/main"/>
+          <a:lstStyle xmlns:a="http://schemas.openxmlformats.org/drawingml/2006/main"/>
+          <a:p xmlns:a="http://schemas.openxmlformats.org/drawingml/2006/main">
             <a:r>
               <a:t>For anyone who is not the discoverer, there are two alternatives: exploration, and following, emulation, and study.</a:t>
             </a:r>
           </a:p>
-          <a:p/>
-          <a:p>
+          <a:p xmlns:a="http://schemas.openxmlformats.org/drawingml/2006/main">
+            <a:r>
+              <a:t/>
+            </a:r>
+          </a:p>
+          <a:p xmlns:a="http://schemas.openxmlformats.org/drawingml/2006/main">
             <a:r>
               <a:t>Exploration is an inventive realisation studied comprehensively, from the extreme of decline to the highest development and awakening. It is the route of a seeker accomplished in samadhi, who establishes themself in just behaviour and dharma-based thought through practice and then develops towards realisation of the omnipresent. The darshan does not recommend the samadhi route as the general way, for the reasons given in Part Two.</a:t>
             </a:r>
           </a:p>
-          <a:p/>
-          <a:p>
-            <a:r>
-              <a:t>The second path is the one open to everyone, and it has two programmes: following or emulating just behaviour, and being and abiding in resolved, dharma-based thought. Firmness and dedication in these two give the authority for realisation of truth. In the recorded session Nagraj adds that for everyone to undertake samadhi, samyama, and exploration is impractical, and that study is the method by which everyone can arrive.</a:t>
+          <a:p xmlns:a="http://schemas.openxmlformats.org/drawingml/2006/main">
+            <a:r>
+              <a:t/>
+            </a:r>
+          </a:p>
+          <a:p xmlns:a="http://schemas.openxmlformats.org/drawingml/2006/main">
+            <a:r>
+              <a:t>The second path is the one open to everyone, and it has two programmes: following or emulating just behaviour, and being and abiding in resolved, dharma-based thought. Firmness and dedication in these two give the authority for realisation of truth. Inquiry with study makes the understanding available for each learner to examine (AVD pp. 225–226).</a:t>
             </a:r>
           </a:p>
         </p:txBody>
@@ -1597,29 +1683,41 @@
         </p:nvSpPr>
         <p:spPr/>
         <p:txBody>
-          <a:bodyPr/>
-          <a:lstStyle/>
-          <a:p>
+          <a:bodyPr xmlns:a="http://schemas.openxmlformats.org/drawingml/2006/main"/>
+          <a:lstStyle xmlns:a="http://schemas.openxmlformats.org/drawingml/2006/main"/>
+          <a:p xmlns:a="http://schemas.openxmlformats.org/drawingml/2006/main">
             <a:r>
               <a:t>Upasana, inherited as devotional practice towards deities, is given a different content: it is the process of refining and transforming the fundamental tendencies, and this study also transforms sanskar and essential nature.</a:t>
             </a:r>
           </a:p>
-          <a:p/>
-          <a:p>
+          <a:p xmlns:a="http://schemas.openxmlformats.org/drawingml/2006/main">
+            <a:r>
+              <a:t/>
+            </a:r>
+          </a:p>
+          <a:p xmlns:a="http://schemas.openxmlformats.org/drawingml/2006/main">
             <a:r>
               <a:t>The fundamental tendencies are the antahkarana's hope, thought, desire, and resoluteness. The awakening of activity-power is the right use, rather than the waste, of the powers exercised through the senses; the awakening of desire-power is the right use of the fundamental tendencies; and the awakening of knowledge-power is right enlightenment together with complete realisation.</a:t>
             </a:r>
           </a:p>
-          <a:p/>
-          <a:p>
+          <a:p xmlns:a="http://schemas.openxmlformats.org/drawingml/2006/main">
+            <a:r>
+              <a:t/>
+            </a:r>
+          </a:p>
+          <a:p xmlns:a="http://schemas.openxmlformats.org/drawingml/2006/main">
             <a:r>
               <a:t>Upasana is itself a form of study, and it continues as study until one is complete in one's own dharma. Of its three kinds, atmastha upasana is reflection itself, and every human being is bound to it. Its disciplines include truthfulness, non-violence, non-possession, and non-stealing, practised as restraint, with gratitude as the basis of restraint from beginning to end.</a:t>
             </a:r>
           </a:p>
-          <a:p/>
-          <a:p>
-            <a:r>
-              <a:t>It succeeds when aim, seeker, and means are held together, and fails when they are separated. And it has no private phase: wisdom and jeevan-value — resolution and prosperity — are its direct results, and sociality is contained in them.</a:t>
+          <a:p xmlns:a="http://schemas.openxmlformats.org/drawingml/2006/main">
+            <a:r>
+              <a:t/>
+            </a:r>
+          </a:p>
+          <a:p xmlns:a="http://schemas.openxmlformats.org/drawingml/2006/main">
+            <a:r>
+              <a:t>It succeeds when aim, seeker, and means are held together, and fails when they are separated. Its purpose and fulfilment include living in relationships: behaviour with equals and practice towards greater awakening. Wisdom and jeevan-value, resolution and prosperity, are its direct results, and sociality is contained in them (KD p. 37). This relational purpose includes the work of reflection.</a:t>
             </a:r>
           </a:p>
         </p:txBody>
@@ -1685,21 +1783,29 @@
         </p:nvSpPr>
         <p:spPr/>
         <p:txBody>
-          <a:bodyPr/>
-          <a:lstStyle/>
-          <a:p>
-            <a:r>
-              <a:t>Dhyan is redefined in the same spirit. The meditation the traditions recommend aims to limit thought to one point until thought ceases. The darshan gives concentration a different object: focusing mun, vritti, chitta, and buddhi for understanding, and focusing them for the purpose of evidence after understanding and realisation. All humans possess this capacity.</a:t>
-            </a:r>
-          </a:p>
-          <a:p/>
-          <a:p>
+          <a:bodyPr xmlns:a="http://schemas.openxmlformats.org/drawingml/2006/main"/>
+          <a:lstStyle xmlns:a="http://schemas.openxmlformats.org/drawingml/2006/main"/>
+          <a:p xmlns:a="http://schemas.openxmlformats.org/drawingml/2006/main">
+            <a:r>
+              <a:t>Nagraj describes the inherited method he pursued as narrowing thought towards cessation (AVD pp. 71–74, 164, 219). That account concerns his practice and does not define every traditional contemplative method. Madhyasth dhyan gives concentration an explicit object: focusing mun, vritti, chitta, and buddhi for understanding, and focusing them for the purpose of evidence after understanding and realisation. All humans possess this capacity.</a:t>
+            </a:r>
+          </a:p>
+          <a:p xmlns:a="http://schemas.openxmlformats.org/drawingml/2006/main">
+            <a:r>
+              <a:t/>
+            </a:r>
+          </a:p>
+          <a:p xmlns:a="http://schemas.openxmlformats.org/drawingml/2006/main">
             <a:r>
               <a:t>Concentration belongs to the inward regulation, antarniyaman, through which enlightenment of the self happens, and atma-bodh is the highest accomplishment of concentration.</a:t>
             </a:r>
           </a:p>
-          <a:p/>
-          <a:p>
+          <a:p xmlns:a="http://schemas.openxmlformats.org/drawingml/2006/main">
+            <a:r>
+              <a:t/>
+            </a:r>
+          </a:p>
+          <a:p xmlns:a="http://schemas.openxmlformats.org/drawingml/2006/main">
             <a:r>
               <a:t>Yog is redefined too. It is union — not posture or breath — and the realisation of the self is attained through yog in the tradition: the union of body and jeevan, and union with awakened humans for awakening. That is why humans seek association with those more awakened than themselves. The practice vocabulary is kept, and each term is given a content defined by understanding and conduct.</a:t>
             </a:r>
@@ -1767,23 +1873,31 @@
         </p:nvSpPr>
         <p:spPr/>
         <p:txBody>
-          <a:bodyPr/>
-          <a:lstStyle/>
-          <a:p>
+          <a:bodyPr xmlns:a="http://schemas.openxmlformats.org/drawingml/2006/main"/>
+          <a:lstStyle xmlns:a="http://schemas.openxmlformats.org/drawingml/2006/main"/>
+          <a:p xmlns:a="http://schemas.openxmlformats.org/drawingml/2006/main">
             <a:r>
               <a:t>The darshan names the conditions of each step, and these are among the most practical statements in the account.</a:t>
             </a:r>
           </a:p>
-          <a:p/>
-          <a:p>
+          <a:p xmlns:a="http://schemas.openxmlformats.org/drawingml/2006/main">
+            <a:r>
+              <a:t/>
+            </a:r>
+          </a:p>
+          <a:p xmlns:a="http://schemas.openxmlformats.org/drawingml/2006/main">
             <a:r>
               <a:t>The reflection of hope succeeds in the absence of crime, and its support is the influence of orderliness. The reflection of thought succeeds in the absence of injustice, supported by social conduct. The reflection of desire succeeds in the absence of attachment, supported by study and sanskar. And the reflection of resolve succeeds in the absence of ignorance, supported by inward regulation or concentration. Only when condition and support are both present does reflection succeed; otherwise it fails.</a:t>
             </a:r>
           </a:p>
-          <a:p/>
-          <a:p>
-            <a:r>
-              <a:t>This lets a practitioner see where in the circuit a failure lies: in crime, injustice, attachment, or ignorance. And the level of awakening a person has reached is judged by their attachment or non-attachment to the body's instincts and the objects of the senses.</a:t>
+          <a:p xmlns:a="http://schemas.openxmlformats.org/drawingml/2006/main">
+            <a:r>
+              <a:t/>
+            </a:r>
+          </a:p>
+          <a:p xmlns:a="http://schemas.openxmlformats.org/drawingml/2006/main">
+            <a:r>
+              <a:t>This lets a practitioner examine where reflection fails: in crime, injustice, attachment, or ignorance. And the level of awakening a person has reached is judged by their attachment or non-attachment to the body's instincts and the objects of the senses.</a:t>
             </a:r>
           </a:p>
         </p:txBody>
@@ -1849,23 +1963,41 @@
         </p:nvSpPr>
         <p:spPr/>
         <p:txBody>
-          <a:bodyPr/>
-          <a:lstStyle/>
-          <a:p>
+          <a:bodyPr xmlns:a="http://schemas.openxmlformats.org/drawingml/2006/main"/>
+          <a:lstStyle xmlns:a="http://schemas.openxmlformats.org/drawingml/2006/main"/>
+          <a:p xmlns:a="http://schemas.openxmlformats.org/drawingml/2006/main">
             <a:r>
               <a:t>Each faculty reaches its complete development by receiving the signal of the one within it: mun by acquiring the receptivity for just behaviour on accepting the signals of vritti; vritti by the ability to form dharma-based thought on accepting the signals of chitta; chitta by the capacity for creative visualisation according to the signals of buddhi in the presence of truth; buddhi by accepting the signals of atma; and atma in realisation in coexistence.</a:t>
             </a:r>
           </a:p>
-          <a:p/>
-          <a:p>
+          <a:p xmlns:a="http://schemas.openxmlformats.org/drawingml/2006/main">
+            <a:r>
+              <a:t/>
+            </a:r>
+          </a:p>
+          <a:p xmlns:a="http://schemas.openxmlformats.org/drawingml/2006/main">
             <a:r>
               <a:t>Each step has its mark. When mun receives the signal of vritti, just behaviour and affection follow; when vritti receives that of chitta, peace; when chitta receives that of buddhi, contentment and self-governed living; and when buddhi receives that of atma, enlightenment of the self and resolve in truth.</a:t>
             </a:r>
           </a:p>
-          <a:p/>
-          <a:p>
+          <a:p xmlns:a="http://schemas.openxmlformats.org/drawingml/2006/main">
+            <a:r>
+              <a:t/>
+            </a:r>
+          </a:p>
+          <a:p xmlns:a="http://schemas.openxmlformats.org/drawingml/2006/main">
             <a:r>
               <a:t>The concurrences name the same progression: concurrence of mun and vritti is happiness, of vritti and chitta peace, of chitta and buddhi contentment, and of buddhi and atma bliss. The eternal concurrence of atma with the omnipresent is ultimate bliss.</a:t>
+            </a:r>
+          </a:p>
+          <a:p xmlns:a="http://schemas.openxmlformats.org/drawingml/2006/main">
+            <a:r>
+              <a:t/>
+            </a:r>
+          </a:p>
+          <a:p xmlns:a="http://schemas.openxmlformats.org/drawingml/2006/main">
+            <a:r>
+              <a:t>These terms have defined content. Peace is behaviour based on resolved thought. Contentment is the absence of the sentiment of lacking. Bliss is complete enlightenment of mediative activity, or atma-bodh (MVD pp. 323–325). They name established understanding and its expression in living, which the learner examines through conduct and continuity.</a:t>
             </a:r>
           </a:p>
         </p:txBody>
@@ -2013,29 +2145,41 @@
         </p:nvSpPr>
         <p:spPr/>
         <p:txBody>
-          <a:bodyPr/>
-          <a:lstStyle/>
-          <a:p>
+          <a:bodyPr xmlns:a="http://schemas.openxmlformats.org/drawingml/2006/main"/>
+          <a:lstStyle xmlns:a="http://schemas.openxmlformats.org/drawingml/2006/main"/>
+          <a:p xmlns:a="http://schemas.openxmlformats.org/drawingml/2006/main">
             <a:r>
               <a:t>What practice yields is liberation from delusion, and the darshan describes it in the traditions' own vocabulary.</a:t>
             </a:r>
           </a:p>
-          <a:p/>
-          <a:p>
+          <a:p xmlns:a="http://schemas.openxmlformats.org/drawingml/2006/main">
+            <a:r>
+              <a:t/>
+            </a:r>
+          </a:p>
+          <a:p xmlns:a="http://schemas.openxmlformats.org/drawingml/2006/main">
             <a:r>
               <a:t>Freedom from the bondage of delusion is moksha, and this is the evidence of awakening. The complete acceptance and realisation of the mortality of the body, the immortality and continuity of jeevan, and the laws of work and behaviour is seedless thought; behaviour in accordance with it is seedless behaviour; and this is liberation from delusion.</a:t>
             </a:r>
           </a:p>
-          <a:p/>
-          <a:p>
+          <a:p xmlns:a="http://schemas.openxmlformats.org/drawingml/2006/main">
+            <a:r>
+              <a:t/>
+            </a:r>
+          </a:p>
+          <a:p xmlns:a="http://schemas.openxmlformats.org/drawingml/2006/main">
             <a:r>
               <a:t>The jeevan-mukta, one liberated while living, has moved irreversibly out of animal consciousness and delusion, does not suffer from the recollection of the past or apprehension of the future, and has no resistance with the present. Nurturing and advancing human society is their essential nature.</a:t>
             </a:r>
           </a:p>
-          <a:p/>
-          <a:p>
-            <a:r>
-              <a:t>The state of realisation is named kaivalya, absoluteness, in which there is liberation from suffering, resentment, fear, and the bondage of delusion. Kaivalya is evidenced as participation in the whole of orderliness together with expression, communication, and exposition, and it lies in awakening, "and not in moksha". For one who is evidence in that state, no further bodily journeys are needed.</a:t>
+          <a:p xmlns:a="http://schemas.openxmlformats.org/drawingml/2006/main">
+            <a:r>
+              <a:t/>
+            </a:r>
+          </a:p>
+          <a:p xmlns:a="http://schemas.openxmlformats.org/drawingml/2006/main">
+            <a:r>
+              <a:t>The state of realisation is named kaivalya, absoluteness, in which there is liberation from suffering, resentment, fear, and the bondage of delusion. Kaivalya is evidenced as participation in the whole of orderliness together with expression, communication, and exposition (AVD pp. 260–261). The doctrine also states that one who evidences this state needs no further bodily journeys.</a:t>
             </a:r>
           </a:p>
         </p:txBody>
@@ -2101,21 +2245,29 @@
         </p:nvSpPr>
         <p:spPr/>
         <p:txBody>
-          <a:bodyPr/>
-          <a:lstStyle/>
-          <a:p>
+          <a:bodyPr xmlns:a="http://schemas.openxmlformats.org/drawingml/2006/main"/>
+          <a:lstStyle xmlns:a="http://schemas.openxmlformats.org/drawingml/2006/main"/>
+          <a:p xmlns:a="http://schemas.openxmlformats.org/drawingml/2006/main">
             <a:r>
               <a:t>The summary answers the deck's questions in a line each.</a:t>
             </a:r>
           </a:p>
-          <a:p/>
-          <a:p>
-            <a:r>
-              <a:t>Realisation is the understanding of existence as coexistence, of jeevan, and of humane conduct. It is the point of satisfaction in definitive understanding — knowing, believing, and recognising. It is an activity of atma whose effect reaches every faculty. It is evidenced in conveyability, just conduct, successful work with nature, and awakened tradition. And it is not an absorbed state, a feeling, or a vision.</a:t>
-            </a:r>
-          </a:p>
-          <a:p/>
-          <a:p>
+          <a:p xmlns:a="http://schemas.openxmlformats.org/drawingml/2006/main">
+            <a:r>
+              <a:t/>
+            </a:r>
+          </a:p>
+          <a:p xmlns:a="http://schemas.openxmlformats.org/drawingml/2006/main">
+            <a:r>
+              <a:t>Realisation is the understanding of existence as coexistence, of jeevan, and of humane conduct. It is the point of satisfaction in definitive understanding — knowing, believing, and recognising. It is an activity of atma whose effect reaches every faculty. It is evidenced in conveyability, just conduct, successful work with nature, and awakened tradition. The attained state has definite content, and that understanding finds continuous expression in living.</a:t>
+            </a:r>
+          </a:p>
+          <a:p xmlns:a="http://schemas.openxmlformats.org/drawingml/2006/main">
+            <a:r>
+              <a:t/>
+            </a:r>
+          </a:p>
+          <a:p xmlns:a="http://schemas.openxmlformats.org/drawingml/2006/main">
             <a:r>
               <a:t>The practitioner studies the stated system, with inquiry and dedication; follows just behaviour and abides in resolved, dharma-based thought; refines hope, thought, desire, and resoluteness through upasana and restraint; concentrates for understanding, in the company of the awakened; and lives the understanding in relationships, until all ten activities of jeevan are effective and the 122 conducts become evident.</a:t>
             </a:r>
@@ -2183,21 +2335,29 @@
         </p:nvSpPr>
         <p:spPr/>
         <p:txBody>
-          <a:bodyPr/>
-          <a:lstStyle/>
-          <a:p>
-            <a:r>
-              <a:t>The darshan states the dependencies of realisation without concealing that they close in a circle. The ability of realisation in knowledge depends on human awakening; awakening depends on sanskar; the development of sanskar depends on environment, study, and endeavour; these depend on humaneness and higher humaneness; and humaneness depends on the ability of realisation in knowledge.</a:t>
-            </a:r>
-          </a:p>
-          <a:p/>
-          <a:p>
-            <a:r>
-              <a:t>The way into the circle is study and participation. Learning can begin before awakening is complete: belief can follow knowing, and knowing can follow belief.</a:t>
-            </a:r>
-          </a:p>
-          <a:p/>
-          <a:p>
+          <a:bodyPr xmlns:a="http://schemas.openxmlformats.org/drawingml/2006/main"/>
+          <a:lstStyle xmlns:a="http://schemas.openxmlformats.org/drawingml/2006/main"/>
+          <a:p xmlns:a="http://schemas.openxmlformats.org/drawingml/2006/main">
+            <a:r>
+              <a:t>The darshan states mutually supporting dependencies concerning the ability for realisation. The ability of realisation in knowledge depends on human awakening; awakening depends on sanskar; the development of sanskar depends on environment, study, and endeavour; these depend on humaneness and higher humaneness; and humaneness depends on the ability of realisation in knowledge.</a:t>
+            </a:r>
+          </a:p>
+          <a:p xmlns:a="http://schemas.openxmlformats.org/drawingml/2006/main">
+            <a:r>
+              <a:t/>
+            </a:r>
+          </a:p>
+          <a:p xmlns:a="http://schemas.openxmlformats.org/drawingml/2006/main">
+            <a:r>
+              <a:t>The learner's entry is study and participation. These dependencies concern developing ability, so they do not require completed realisation before study begins. Learning can begin before awakening is complete: belief can follow knowing, and knowing can follow belief.</a:t>
+            </a:r>
+          </a:p>
+          <a:p xmlns:a="http://schemas.openxmlformats.org/drawingml/2006/main">
+            <a:r>
+              <a:t/>
+            </a:r>
+          </a:p>
+          <a:p xmlns:a="http://schemas.openxmlformats.org/drawingml/2006/main">
             <a:r>
               <a:t>So the practical conclusion of this deck is simple to state and demanding to live: study the stated system with inquiry and dedication, bring conduct into line with just behaviour and resolved thought, refine the tendencies, and let the understanding show in relationships. That is where the darshan asks to be tested.</a:t>
             </a:r>
@@ -2511,33 +2671,59 @@
         </p:nvSpPr>
         <p:spPr/>
         <p:txBody>
-          <a:bodyPr/>
-          <a:lstStyle/>
-          <a:p>
+          <a:bodyPr xmlns:a="http://schemas.openxmlformats.org/drawingml/2006/main"/>
+          <a:lstStyle xmlns:a="http://schemas.openxmlformats.org/drawingml/2006/main"/>
+          <a:p xmlns:a="http://schemas.openxmlformats.org/drawingml/2006/main">
             <a:r>
               <a:t>The content of realisation is given as three kinds of knowledge: of existence as coexistence, of jeevan, and of humane conduct.</a:t>
             </a:r>
           </a:p>
-          <a:p/>
-          <a:p>
+          <a:p xmlns:a="http://schemas.openxmlformats.org/drawingml/2006/main">
+            <a:r>
+              <a:t/>
+            </a:r>
+          </a:p>
+          <a:p xmlns:a="http://schemas.openxmlformats.org/drawingml/2006/main">
             <a:r>
               <a:t>To understand any existing thing is to understand its form, property, essential nature, and innateness — rup, gun, swabhav, and dharma. Form, property, and essential nature can be understood; dharma, innateness, can only be realised.</a:t>
             </a:r>
           </a:p>
-          <a:p/>
-          <a:p>
+          <a:p xmlns:a="http://schemas.openxmlformats.org/drawingml/2006/main">
+            <a:r>
+              <a:t/>
+            </a:r>
+          </a:p>
+          <a:p xmlns:a="http://schemas.openxmlformats.org/drawingml/2006/main">
+            <a:r>
+              <a:t>Dharma names a unit's innateness. Human dharma is continuous happiness, expressed through resolved thought and participation in orderliness (MVD pp. 51, 156; JV p. 121). This connects the meaning of innateness with dharma in humane thought.</a:t>
+            </a:r>
+          </a:p>
+          <a:p xmlns:a="http://schemas.openxmlformats.org/drawingml/2006/main">
+            <a:r>
+              <a:t/>
+            </a:r>
+          </a:p>
+          <a:p xmlns:a="http://schemas.openxmlformats.org/drawingml/2006/main">
             <a:r>
               <a:t>Knowledge of jeevan is knowledge of the knower itself: its constitution and its activities, which Part Three examines.</a:t>
             </a:r>
           </a:p>
-          <a:p/>
-          <a:p>
+          <a:p xmlns:a="http://schemas.openxmlformats.org/drawingml/2006/main">
+            <a:r>
+              <a:t/>
+            </a:r>
+          </a:p>
+          <a:p xmlns:a="http://schemas.openxmlformats.org/drawingml/2006/main">
             <a:r>
               <a:t>Knowledge of humane conduct is specified by justice, dharma, and truth, and these are levels of realisation itself. Justice is realisation manifest in behaviour, dharma is realisation manifest in thought, and coexistence is the ultimate truth realised in atma.</a:t>
             </a:r>
           </a:p>
-          <a:p/>
-          <a:p>
+          <a:p xmlns:a="http://schemas.openxmlformats.org/drawingml/2006/main">
+            <a:r>
+              <a:t/>
+            </a:r>
+          </a:p>
+          <a:p xmlns:a="http://schemas.openxmlformats.org/drawingml/2006/main">
             <a:r>
               <a:t>Complete enlightenment is the enlightenment of these three, and it is called enlightenment of the self. The awakened human is aware of their own being and of the being of the whole of existence.</a:t>
             </a:r>
@@ -2605,21 +2791,29 @@
         </p:nvSpPr>
         <p:spPr/>
         <p:txBody>
-          <a:bodyPr/>
-          <a:lstStyle/>
-          <a:p>
+          <a:bodyPr xmlns:a="http://schemas.openxmlformats.org/drawingml/2006/main"/>
+          <a:lstStyle xmlns:a="http://schemas.openxmlformats.org/drawingml/2006/main"/>
+          <a:p xmlns:a="http://schemas.openxmlformats.org/drawingml/2006/main">
             <a:r>
               <a:t>This is the central definition. Definitive understanding, avdharana, is knowing, believing, and recognising together. Realisation is attaining the point of satisfaction in them. Authenticity is expressing that realisation in actions and behaviour and in systems of living.</a:t>
             </a:r>
           </a:p>
-          <a:p/>
-          <a:p>
-            <a:r>
-              <a:t>Realisation therefore adds no new object to what definitive understanding already holds. It is the point at which that understanding reaches satisfaction, and authenticity is how it shows. In a recorded session from 2010, Nagraj was asked what more is understood in anubhav than in bodh. His answer: nothing further — what occurred in direct recognition becomes firm.</a:t>
-            </a:r>
-          </a:p>
-          <a:p/>
-          <a:p>
+          <a:p xmlns:a="http://schemas.openxmlformats.org/drawingml/2006/main">
+            <a:r>
+              <a:t/>
+            </a:r>
+          </a:p>
+          <a:p xmlns:a="http://schemas.openxmlformats.org/drawingml/2006/main">
+            <a:r>
+              <a:t>Realisation therefore adds no new object to what definitive understanding already holds. It is the point at which that understanding reaches satisfaction, and authenticity is how it shows. The definition relates satisfaction to the content already known, believed, and recognised, and authenticity to its expression in conduct and systems (AVD p. 224).</a:t>
+            </a:r>
+          </a:p>
+          <a:p xmlns:a="http://schemas.openxmlformats.org/drawingml/2006/main">
+            <a:r>
+              <a:t/>
+            </a:r>
+          </a:p>
+          <a:p xmlns:a="http://schemas.openxmlformats.org/drawingml/2006/main">
             <a:r>
               <a:t>Realisation is realisation in the ultimate truth, which is coexistence, and it is distinguished from contemplation, which is the awareness of truth. Awakening, correspondingly, is knowing, believing, recognising, and fulfilling jeevan and existence as they are.</a:t>
             </a:r>
@@ -2687,29 +2881,51 @@
         </p:nvSpPr>
         <p:spPr/>
         <p:txBody>
-          <a:bodyPr/>
-          <a:lstStyle/>
-          <a:p>
-            <a:r>
-              <a:t>Realisation is the third of four stages — sakshatkar, bodh, anubhav, praman — and the stages fall on the faculties of jeevan.</a:t>
-            </a:r>
-          </a:p>
-          <a:p/>
-          <a:p>
-            <a:r>
-              <a:t>Affirmation of truth in the form of coexistence through study begins as manan, ratiocination, in mun, and as tulan, deliberation by the qualitative method, in vritti. It becomes sakshatkar, direct recognition, in chitta, and bodh, enlightenment and acceptance, in buddhi. Anubhav, realisation, is in atma.</a:t>
-            </a:r>
-          </a:p>
-          <a:p/>
-          <a:p>
-            <a:r>
-              <a:t>Praman, evidence, is the fourth stage, and it is not a report issued after the fact. Realisation is the ultimate evidence, understanding is manifest in resolution, work, and behaviour, and evidence is awakened tradition. Only awakened humans are recognisable in the seer status.</a:t>
-            </a:r>
-          </a:p>
-          <a:p/>
-          <a:p>
-            <a:r>
-              <a:t>Nagraj describes the same order in his own case: realisation attained after revelation and definitive understanding, with contemplation following from that enlightenment. In the 2010 recorded session he adds that the weight of the sequence falls on sakshatkar, which he calls the success of study, and that praman is the power to bring about understanding in another.</a:t>
+          <a:bodyPr xmlns:a="http://schemas.openxmlformats.org/drawingml/2006/main"/>
+          <a:lstStyle xmlns:a="http://schemas.openxmlformats.org/drawingml/2006/main"/>
+          <a:p xmlns:a="http://schemas.openxmlformats.org/drawingml/2006/main">
+            <a:r>
+              <a:t>Teacher-guided study involves shravan, manan, and arth-bodh: listening, reflection, and understanding meaning (MVD p. 257). Listening gives the learner an entry into study. Reflection and understanding continue as the meaning becomes clear.</a:t>
+            </a:r>
+          </a:p>
+          <a:p xmlns:a="http://schemas.openxmlformats.org/drawingml/2006/main">
+            <a:r>
+              <a:t/>
+            </a:r>
+          </a:p>
+          <a:p xmlns:a="http://schemas.openxmlformats.org/drawingml/2006/main">
+            <a:r>
+              <a:t>Affirmation of coexistence through study is named manan in mun, tulan in vritti, sakshatkar in chitta, and bodh in buddhi. Here manan concerns acceptance and tulan qualitative deliberation (MVD p. 126). These are related faculty functions. They do not prescribe separate periods in which one must finish before the next starts. The full development of mun also involves reflection upon the justice-based thoughts of vritti (MVD p. 295).</a:t>
+            </a:r>
+          </a:p>
+          <a:p xmlns:a="http://schemas.openxmlformats.org/drawingml/2006/main">
+            <a:r>
+              <a:t/>
+            </a:r>
+          </a:p>
+          <a:p xmlns:a="http://schemas.openxmlformats.org/drawingml/2006/main">
+            <a:r>
+              <a:t>Direct recognition, understanding, realisation, and evidence distinguish connected aspects of accomplishment and expression. Nagraj describes sakshatkar, definitive understanding, and realisation in that order in his own case (JV p. 62). Complete bodh in buddhi coincides with anubhav in atma (MVD p. 207). Atma-bodh and realisation in coexistence become effective together (MVD pp. 286–287).</a:t>
+            </a:r>
+          </a:p>
+          <a:p xmlns:a="http://schemas.openxmlformats.org/drawingml/2006/main">
+            <a:r>
+              <a:t/>
+            </a:r>
+          </a:p>
+          <a:p xmlns:a="http://schemas.openxmlformats.org/drawingml/2006/main">
+            <a:r>
+              <a:t>Realisation is the ultimate evidence. Understanding manifests in resolution, work, and behaviour, and evidence is awakened tradition (MVD p. 12). What is understood can be communicated and lived. The diagram distinguishes these relationships without imposing a waiting period between complete understanding and realisation.</a:t>
+            </a:r>
+          </a:p>
+          <a:p xmlns:a="http://schemas.openxmlformats.org/drawingml/2006/main">
+            <a:r>
+              <a:t/>
+            </a:r>
+          </a:p>
+          <a:p xmlns:a="http://schemas.openxmlformats.org/drawingml/2006/main">
+            <a:r>
+              <a:t>Shravan means listening. It is distinct from shruti, realised articulation or communication of understanding (MVD pp. 324, 329). Focused attention for understanding and evidence is dhyan (MVD pp. 284–285).</a:t>
             </a:r>
           </a:p>
         </p:txBody>
@@ -6555,7 +6771,7 @@
             <a:noAutofit/>
           </a:bodyPr>
           <a:lstStyle/>
-          <a:p>
+          <a:p xmlns:a="http://schemas.openxmlformats.org/drawingml/2006/main">
             <a:pPr algn="l">
               <a:spcBef>
                 <a:spcPts val="0"/>
@@ -6563,6 +6779,7 @@
               <a:spcAft>
                 <a:spcPts val="0"/>
               </a:spcAft>
+              <a:buNone/>
             </a:pPr>
             <a:r>
               <a:rPr sz="1250" b="1" i="0">
@@ -6570,8 +6787,10 @@
                   <a:srgbClr val="1E2447"/>
                 </a:solidFill>
                 <a:latin typeface="Calibri"/>
-              </a:rPr>
-              <a:t>An inner state cannot be its own credential. Evidence is threefold — realisation, behaviour, and experiment (MVD p. 12) — and the awakened human is its basis (SB p. 5).</a:t>
+                <a:ea typeface="Calibri"/>
+                <a:cs typeface="Calibri"/>
+              </a:rPr>
+              <a:t>A claim of realisation must become evident in living. Evidence includes realisation, behaviour, and experiment (MVD p. 12), with the awakened human as its basis (SB p. 5).</a:t>
             </a:r>
           </a:p>
         </p:txBody>
@@ -7507,7 +7726,7 @@
             <a:noAutofit/>
           </a:bodyPr>
           <a:lstStyle/>
-          <a:p>
+          <a:p xmlns:a="http://schemas.openxmlformats.org/drawingml/2006/main">
             <a:pPr algn="l">
               <a:spcBef>
                 <a:spcPts val="0"/>
@@ -7515,6 +7734,7 @@
               <a:spcAft>
                 <a:spcPts val="0"/>
               </a:spcAft>
+              <a:buNone/>
             </a:pPr>
             <a:r>
               <a:rPr sz="1600" b="0" i="1">
@@ -7522,8 +7742,10 @@
                   <a:srgbClr val="C9D4EF"/>
                 </a:solidFill>
                 <a:latin typeface="Calibri"/>
-              </a:rPr>
-              <a:t>The founder attained samadhi and found no knowing in it. Practice removes delusion — not the activity of jeevan.</a:t>
+                <a:ea typeface="Calibri"/>
+                <a:cs typeface="Calibri"/>
+              </a:rPr>
+              <a:t>The founder attained samadhi, but his foundational questions remained unanswered. Practice removes delusion while jeevan's activity continues.</a:t>
             </a:r>
           </a:p>
         </p:txBody>
@@ -7788,7 +8010,7 @@
             <a:noAutofit/>
           </a:bodyPr>
           <a:lstStyle/>
-          <a:p>
+          <a:p xmlns:a="http://schemas.openxmlformats.org/drawingml/2006/main">
             <a:pPr algn="l">
               <a:spcBef>
                 <a:spcPts val="0"/>
@@ -7796,6 +8018,7 @@
               <a:spcAft>
                 <a:spcPts val="0"/>
               </a:spcAft>
+              <a:buNone/>
             </a:pPr>
             <a:r>
               <a:rPr sz="3000" b="1" i="0">
@@ -7803,8 +8026,10 @@
                   <a:srgbClr val="1E2447"/>
                 </a:solidFill>
                 <a:latin typeface="Cambria"/>
-              </a:rPr>
-              <a:t>Samadhi Without Knowing</a:t>
+                <a:ea typeface="Cambria"/>
+                <a:cs typeface="Cambria"/>
+              </a:rPr>
+              <a:t>Samadhi and Unanswered Questions</a:t>
             </a:r>
           </a:p>
         </p:txBody>
@@ -8379,7 +8604,7 @@
             <a:noAutofit/>
           </a:bodyPr>
           <a:lstStyle/>
-          <a:p>
+          <a:p xmlns:a="http://schemas.openxmlformats.org/drawingml/2006/main">
             <a:pPr algn="l">
               <a:spcBef>
                 <a:spcPts val="0"/>
@@ -8387,6 +8612,7 @@
               <a:spcAft>
                 <a:spcPts val="0"/>
               </a:spcAft>
+              <a:buNone/>
             </a:pPr>
             <a:r>
               <a:rPr sz="1200" b="0" i="1">
@@ -8394,8 +8620,10 @@
                   <a:srgbClr val="1E2447"/>
                 </a:solidFill>
                 <a:latin typeface="Calibri"/>
-              </a:rPr>
-              <a:t>Two claims: in samadhi no knowing occurs, and a state with nothing to describe cannot serve as evidence — even of itself.</a:t>
+                <a:ea typeface="Calibri"/>
+                <a:cs typeface="Calibri"/>
+              </a:rPr>
+              <a:t>Nagraj's questions remained unanswered, and he could not describe what would evidence the attained state.</a:t>
             </a:r>
           </a:p>
         </p:txBody>
@@ -9867,7 +10095,7 @@
             <a:noAutofit/>
           </a:bodyPr>
           <a:lstStyle/>
-          <a:p>
+          <a:p xmlns:a="http://schemas.openxmlformats.org/drawingml/2006/main">
             <a:pPr algn="l">
               <a:spcBef>
                 <a:spcPts val="0"/>
@@ -9875,6 +10103,7 @@
               <a:spcAft>
                 <a:spcPts val="0"/>
               </a:spcAft>
+              <a:buNone/>
             </a:pPr>
             <a:r>
               <a:rPr sz="1200" b="0" i="0">
@@ -9882,8 +10111,21 @@
                   <a:srgbClr val="5A6377"/>
                 </a:solidFill>
                 <a:latin typeface="Calibri"/>
-              </a:rPr>
-              <a:t>Not revealing understanding, not being able to, or not being able to attain it (MVD p. 273). A lack of understanding, not a property of reality.</a:t>
+                <a:ea typeface="Calibri"/>
+                <a:cs typeface="Calibri"/>
+              </a:rPr>
+              <a:t>Not revealing understanding, not being able to, or not being able to attain it (MVD p. 273). </a:t>
+            </a:r>
+            <a:r>
+              <a:rPr sz="1200" b="0" i="0">
+                <a:solidFill>
+                  <a:srgbClr val="5A6377"/>
+                </a:solidFill>
+                <a:latin typeface="Calibri"/>
+                <a:ea typeface="Calibri"/>
+                <a:cs typeface="Calibri"/>
+              </a:rPr>
+              <a:t>Failure to attain or communicate understanding. Reality itself is knowable.</a:t>
             </a:r>
           </a:p>
         </p:txBody>
@@ -10946,7 +11188,7 @@
             <a:noAutofit/>
           </a:bodyPr>
           <a:lstStyle/>
-          <a:p>
+          <a:p xmlns:a="http://schemas.openxmlformats.org/drawingml/2006/main">
             <a:pPr algn="l">
               <a:spcBef>
                 <a:spcPts val="0"/>
@@ -10954,6 +11196,7 @@
               <a:spcAft>
                 <a:spcPts val="0"/>
               </a:spcAft>
+              <a:buNone/>
             </a:pPr>
             <a:r>
               <a:rPr sz="1600" b="0" i="1">
@@ -10961,8 +11204,10 @@
                   <a:srgbClr val="C9D4EF"/>
                 </a:solidFill>
                 <a:latin typeface="Calibri"/>
-              </a:rPr>
-              <a:t>Practice does not produce a state. It makes effective the activities jeevan already has — through study, refinement, inward regulation, and conduct.</a:t>
+                <a:ea typeface="Calibri"/>
+                <a:cs typeface="Calibri"/>
+              </a:rPr>
+              <a:t>Practice develops understanding and makes jeevan's activities effective through study, refinement, inward regulation, and conduct.</a:t>
             </a:r>
           </a:p>
         </p:txBody>
@@ -13707,7 +13952,7 @@
             <a:noAutofit/>
           </a:bodyPr>
           <a:lstStyle/>
-          <a:p>
+          <a:p xmlns:a="http://schemas.openxmlformats.org/drawingml/2006/main">
             <a:pPr algn="l">
               <a:spcBef>
                 <a:spcPts val="0"/>
@@ -13715,6 +13960,7 @@
               <a:spcAft>
                 <a:spcPts val="0"/>
               </a:spcAft>
+              <a:buNone/>
             </a:pPr>
             <a:r>
               <a:rPr sz="1100" b="1" i="0">
@@ -13722,6 +13968,8 @@
                   <a:srgbClr val="5A6377"/>
                 </a:solidFill>
                 <a:latin typeface="Calibri"/>
+                <a:ea typeface="Calibri"/>
+                <a:cs typeface="Calibri"/>
               </a:rPr>
               <a:t>Buddhi</a:t>
             </a:r>
@@ -13731,8 +13979,32 @@
                   <a:srgbClr val="5A6377"/>
                 </a:solidFill>
                 <a:latin typeface="Calibri"/>
-              </a:rPr>
-              <a:t> — bliss and definiteness; existence and fearlessness</a:t>
+                <a:ea typeface="Calibri"/>
+                <a:cs typeface="Calibri"/>
+              </a:rPr>
+              <a:t> — bliss and </a:t>
+            </a:r>
+            <a:r>
+              <a:rPr sz="1100" b="0" i="0">
+                <a:solidFill>
+                  <a:srgbClr val="5A6377"/>
+                </a:solidFill>
+                <a:latin typeface="Calibri"/>
+                <a:ea typeface="Calibri"/>
+                <a:cs typeface="Calibri"/>
+              </a:rPr>
+              <a:t>dhee</a:t>
+            </a:r>
+            <a:r>
+              <a:rPr sz="1100" b="0" i="0">
+                <a:solidFill>
+                  <a:srgbClr val="5A6377"/>
+                </a:solidFill>
+                <a:latin typeface="Calibri"/>
+                <a:ea typeface="Calibri"/>
+                <a:cs typeface="Calibri"/>
+              </a:rPr>
+              <a:t>; existence and fearlessness</a:t>
             </a:r>
           </a:p>
         </p:txBody>
@@ -13942,7 +14214,7 @@
             <a:noAutofit/>
           </a:bodyPr>
           <a:lstStyle/>
-          <a:p>
+          <a:p xmlns:a="http://schemas.openxmlformats.org/drawingml/2006/main">
             <a:pPr algn="l">
               <a:spcBef>
                 <a:spcPts val="0"/>
@@ -13950,6 +14222,7 @@
               <a:spcAft>
                 <a:spcPts val="0"/>
               </a:spcAft>
+              <a:buNone/>
             </a:pPr>
             <a:r>
               <a:rPr sz="1200" b="1" i="0">
@@ -13957,8 +14230,10 @@
                   <a:srgbClr val="9A6414"/>
                 </a:solidFill>
                 <a:latin typeface="Calibri"/>
-              </a:rPr>
-              <a:t>Bliss, love, reverence, and devotion are conducts of awakened jeevan — not states attained in withdrawal.</a:t>
+                <a:ea typeface="Calibri"/>
+                <a:cs typeface="Calibri"/>
+              </a:rPr>
+              <a:t>Bliss, love, reverence, and devotion name conducts of awakened jeevan, expressed in living.</a:t>
             </a:r>
           </a:p>
         </p:txBody>
@@ -14139,7 +14414,7 @@
             <a:noAutofit/>
           </a:bodyPr>
           <a:lstStyle/>
-          <a:p>
+          <a:p xmlns:a="http://schemas.openxmlformats.org/drawingml/2006/main">
             <a:pPr algn="l">
               <a:spcBef>
                 <a:spcPts val="0"/>
@@ -14147,6 +14422,7 @@
               <a:spcAft>
                 <a:spcPts val="0"/>
               </a:spcAft>
+              <a:buNone/>
             </a:pPr>
             <a:r>
               <a:rPr sz="3000" b="1" i="0">
@@ -14154,8 +14430,10 @@
                   <a:srgbClr val="1E2447"/>
                 </a:solidFill>
                 <a:latin typeface="Cambria"/>
-              </a:rPr>
-              <a:t>Practice Repairs a Circuit</a:t>
+                <a:ea typeface="Cambria"/>
+                <a:cs typeface="Cambria"/>
+              </a:rPr>
+              <a:t>Practice Reorients the Faculties</a:t>
             </a:r>
           </a:p>
         </p:txBody>
@@ -19802,7 +20080,7 @@
             <a:noAutofit/>
           </a:bodyPr>
           <a:lstStyle/>
-          <a:p>
+          <a:p xmlns:a="http://schemas.openxmlformats.org/drawingml/2006/main">
             <a:pPr algn="l">
               <a:spcBef>
                 <a:spcPts val="0"/>
@@ -19810,6 +20088,7 @@
               <a:spcAft>
                 <a:spcPts val="0"/>
               </a:spcAft>
+              <a:buNone/>
             </a:pPr>
             <a:r>
               <a:rPr sz="950" b="0" i="1">
@@ -19817,8 +20096,32 @@
                   <a:srgbClr val="5A6377"/>
                 </a:solidFill>
                 <a:latin typeface="Calibri"/>
-              </a:rPr>
-              <a:t>MVD pp. 274, 284–286, 301  ·  AVD pp. 164, 219  ·  AnalyticMadhyasthDarshan.org  ·  22 / 28</a:t>
+                <a:ea typeface="Calibri"/>
+                <a:cs typeface="Calibri"/>
+              </a:rPr>
+              <a:t>MVD pp. 274, 284–286, 301  ·  </a:t>
+            </a:r>
+            <a:r>
+              <a:rPr sz="950" b="0" i="1">
+                <a:solidFill>
+                  <a:srgbClr val="5A6377"/>
+                </a:solidFill>
+                <a:latin typeface="Calibri"/>
+                <a:ea typeface="Calibri"/>
+                <a:cs typeface="Calibri"/>
+              </a:rPr>
+              <a:t>AVD pp. 71–74, 164, 219</a:t>
+            </a:r>
+            <a:r>
+              <a:rPr sz="950" b="0" i="1">
+                <a:solidFill>
+                  <a:srgbClr val="5A6377"/>
+                </a:solidFill>
+                <a:latin typeface="Calibri"/>
+                <a:ea typeface="Calibri"/>
+                <a:cs typeface="Calibri"/>
+              </a:rPr>
+              <a:t>  ·  AnalyticMadhyasthDarshan.org  ·  22 / 28</a:t>
             </a:r>
           </a:p>
         </p:txBody>
@@ -20019,7 +20322,7 @@
             <a:noAutofit/>
           </a:bodyPr>
           <a:lstStyle/>
-          <a:p>
+          <a:p xmlns:a="http://schemas.openxmlformats.org/drawingml/2006/main">
             <a:pPr algn="l">
               <a:spcBef>
                 <a:spcPts val="0"/>
@@ -20027,6 +20330,7 @@
               <a:spcAft>
                 <a:spcPts val="0"/>
               </a:spcAft>
+              <a:buNone/>
             </a:pPr>
             <a:r>
               <a:rPr sz="1300" b="1" i="0">
@@ -20034,8 +20338,10 @@
                   <a:srgbClr val="1E2447"/>
                 </a:solidFill>
                 <a:latin typeface="Cambria"/>
-              </a:rPr>
-              <a:t>Not stopping thought</a:t>
+                <a:ea typeface="Cambria"/>
+                <a:cs typeface="Cambria"/>
+              </a:rPr>
+              <a:t>Meaning and evidence</a:t>
             </a:r>
           </a:p>
         </p:txBody>
@@ -20061,7 +20367,7 @@
             <a:noAutofit/>
           </a:bodyPr>
           <a:lstStyle/>
-          <a:p>
+          <a:p xmlns:a="http://schemas.openxmlformats.org/drawingml/2006/main">
             <a:pPr algn="l">
               <a:spcBef>
                 <a:spcPts val="0"/>
@@ -20069,6 +20375,7 @@
               <a:spcAft>
                 <a:spcPts val="0"/>
               </a:spcAft>
+              <a:buNone/>
             </a:pPr>
             <a:r>
               <a:rPr sz="1200" b="0" i="0">
@@ -20076,8 +20383,10 @@
                   <a:srgbClr val="5A6377"/>
                 </a:solidFill>
                 <a:latin typeface="Calibri"/>
-              </a:rPr>
-              <a:t>Traditional meditation narrows thought until it ceases (AVD pp. 164, 219). Here the object is meaning and its evidence (MVD pp. 284–285).</a:t>
+                <a:ea typeface="Calibri"/>
+                <a:cs typeface="Calibri"/>
+              </a:rPr>
+              <a:t>Nagraj pursued an inherited method towards thought's cessation (AVD pp. 71–74). Madhyasth dhyan focuses on meaning and its evidence (MVD pp. 284–285).</a:t>
             </a:r>
           </a:p>
         </p:txBody>
@@ -21795,7 +22104,7 @@
             <a:noAutofit/>
           </a:bodyPr>
           <a:lstStyle/>
-          <a:p>
+          <a:p xmlns:a="http://schemas.openxmlformats.org/drawingml/2006/main">
             <a:pPr algn="l">
               <a:spcBef>
                 <a:spcPts val="0"/>
@@ -21803,6 +22112,7 @@
               <a:spcAft>
                 <a:spcPts val="0"/>
               </a:spcAft>
+              <a:buNone/>
             </a:pPr>
             <a:r>
               <a:rPr sz="950" b="0" i="1">
@@ -21810,8 +22120,21 @@
                   <a:srgbClr val="5A6377"/>
                 </a:solidFill>
                 <a:latin typeface="Calibri"/>
-              </a:rPr>
-              <a:t>MVD pp. 282–283, 322–323, 327  ·  AnalyticMadhyasthDarshan.org  ·  24 / 28</a:t>
+                <a:ea typeface="Calibri"/>
+                <a:cs typeface="Calibri"/>
+              </a:rPr>
+              <a:t>MVD pp. 282–283, 322–325, 327</a:t>
+            </a:r>
+            <a:r>
+              <a:rPr sz="950" b="0" i="1">
+                <a:solidFill>
+                  <a:srgbClr val="5A6377"/>
+                </a:solidFill>
+                <a:latin typeface="Calibri"/>
+                <a:ea typeface="Calibri"/>
+                <a:cs typeface="Calibri"/>
+              </a:rPr>
+              <a:t>  ·  AnalyticMadhyasthDarshan.org  ·  24 / 28</a:t>
             </a:r>
           </a:p>
         </p:txBody>
@@ -21837,7 +22160,7 @@
             <a:noAutofit/>
           </a:bodyPr>
           <a:lstStyle/>
-          <a:p>
+          <a:p xmlns:a="http://schemas.openxmlformats.org/drawingml/2006/main">
             <a:pPr algn="l">
               <a:spcBef>
                 <a:spcPts val="0"/>
@@ -21845,6 +22168,7 @@
               <a:spcAft>
                 <a:spcPts val="0"/>
               </a:spcAft>
+              <a:buNone/>
             </a:pPr>
             <a:r>
               <a:rPr sz="1300" b="1" i="0">
@@ -21852,8 +22176,10 @@
                   <a:srgbClr val="1E2447"/>
                 </a:solidFill>
                 <a:latin typeface="Calibri"/>
-              </a:rPr>
-              <a:t>Each faculty reaches its complete development by receiving the signal of the one within it (MVD pp. 322–323).</a:t>
+                <a:ea typeface="Calibri"/>
+                <a:cs typeface="Calibri"/>
+              </a:rPr>
+              <a:t>Each faculty develops through the signal of the one within it. These marks concern understanding expressed in living (MVD pp. 322–325).</a:t>
             </a:r>
           </a:p>
         </p:txBody>
@@ -25497,7 +25823,7 @@
             <a:noAutofit/>
           </a:bodyPr>
           <a:lstStyle/>
-          <a:p>
+          <a:p xmlns:a="http://schemas.openxmlformats.org/drawingml/2006/main">
             <a:pPr algn="l">
               <a:spcBef>
                 <a:spcPts val="0"/>
@@ -25505,6 +25831,7 @@
               <a:spcAft>
                 <a:spcPts val="0"/>
               </a:spcAft>
+              <a:buNone/>
             </a:pPr>
             <a:r>
               <a:rPr sz="1200" b="0" i="0">
@@ -25512,8 +25839,10 @@
                   <a:srgbClr val="5A6377"/>
                 </a:solidFill>
                 <a:latin typeface="Calibri"/>
-              </a:rPr>
-              <a:t>Not an absorbed state, a feeling, or a vision</a:t>
+                <a:ea typeface="Calibri"/>
+                <a:cs typeface="Calibri"/>
+              </a:rPr>
+              <a:t>Understanding expressed continuously in living</a:t>
             </a:r>
           </a:p>
         </p:txBody>
@@ -26384,7 +26713,7 @@
             <a:noAutofit/>
           </a:bodyPr>
           <a:lstStyle/>
-          <a:p>
+          <a:p xmlns:a="http://schemas.openxmlformats.org/drawingml/2006/main">
             <a:pPr algn="l">
               <a:spcBef>
                 <a:spcPts val="0"/>
@@ -26392,6 +26721,7 @@
               <a:spcAft>
                 <a:spcPts val="0"/>
               </a:spcAft>
+              <a:buNone/>
             </a:pPr>
             <a:r>
               <a:rPr sz="1500" b="0" i="1">
@@ -26399,8 +26729,10 @@
                   <a:srgbClr val="C9D4EF"/>
                 </a:solidFill>
                 <a:latin typeface="Calibri"/>
-              </a:rPr>
-              <a:t>Realisation, awakening, and study depend on one another. Study and participation are where the circle is entered.</a:t>
+                <a:ea typeface="Calibri"/>
+                <a:cs typeface="Calibri"/>
+              </a:rPr>
+              <a:t>Ability for realisation develops with awakening, formation, and study. Study and participation provide the learner's entry.</a:t>
             </a:r>
           </a:p>
         </p:txBody>
@@ -26457,7 +26789,7 @@
             <a:noAutofit/>
           </a:bodyPr>
           <a:lstStyle/>
-          <a:p>
+          <a:p xmlns:a="http://schemas.openxmlformats.org/drawingml/2006/main">
             <a:pPr algn="ctr">
               <a:spcBef>
                 <a:spcPts val="0"/>
@@ -26465,6 +26797,7 @@
               <a:spcAft>
                 <a:spcPts val="0"/>
               </a:spcAft>
+              <a:buNone/>
             </a:pPr>
             <a:r>
               <a:rPr sz="1000" b="1" i="0">
@@ -26472,8 +26805,10 @@
                   <a:srgbClr val="FFFFFF"/>
                 </a:solidFill>
                 <a:latin typeface="Cambria"/>
-              </a:rPr>
-              <a:t>Realisation</a:t>
+                <a:ea typeface="Cambria"/>
+                <a:cs typeface="Cambria"/>
+              </a:rPr>
+              <a:t>Ability for</a:t>
             </a:r>
           </a:p>
         </p:txBody>
@@ -26487,7 +26822,7 @@
         <p:spPr>
           <a:xfrm>
             <a:off x="667512" y="4114800"/>
-            <a:ext cx="841248" cy="256032"/>
+            <a:ext cx="841248" cy="292608"/>
           </a:xfrm>
           <a:prstGeom prst="rect">
             <a:avLst/>
@@ -26499,7 +26834,7 @@
             <a:noAutofit/>
           </a:bodyPr>
           <a:lstStyle/>
-          <a:p>
+          <a:p xmlns:a="http://schemas.openxmlformats.org/drawingml/2006/main">
             <a:pPr algn="ctr">
               <a:spcBef>
                 <a:spcPts val="0"/>
@@ -26507,6 +26842,7 @@
               <a:spcAft>
                 <a:spcPts val="0"/>
               </a:spcAft>
+              <a:buNone/>
             </a:pPr>
             <a:r>
               <a:rPr sz="900" b="0" i="1">
@@ -26514,8 +26850,11 @@
                   <a:srgbClr val="C9D4EF"/>
                 </a:solidFill>
                 <a:latin typeface="Calibri"/>
-              </a:rPr>
-              <a:t>in knowledge</a:t>
+                <a:ea typeface="Calibri"/>
+                <a:cs typeface="Calibri"/>
+              </a:rPr>
+              <a:t>realisation in
+knowledge</a:t>
             </a:r>
           </a:p>
         </p:txBody>
@@ -27001,7 +27340,7 @@
             <a:noAutofit/>
           </a:bodyPr>
           <a:lstStyle/>
-          <a:p>
+          <a:p xmlns:a="http://schemas.openxmlformats.org/drawingml/2006/main">
             <a:pPr algn="l">
               <a:spcBef>
                 <a:spcPts val="0"/>
@@ -27009,6 +27348,7 @@
               <a:spcAft>
                 <a:spcPts val="0"/>
               </a:spcAft>
+              <a:buNone/>
             </a:pPr>
             <a:r>
               <a:rPr sz="1100" b="0" i="0">
@@ -27016,8 +27356,10 @@
                   <a:srgbClr val="8E9BC4"/>
                 </a:solidFill>
                 <a:latin typeface="Calibri"/>
-              </a:rPr>
-              <a:t>Each depends on the next; the last on realisation (MVD p. 290).</a:t>
+                <a:ea typeface="Calibri"/>
+                <a:cs typeface="Calibri"/>
+              </a:rPr>
+              <a:t>Mutual support for the ability to realise (MVD p. 290).</a:t>
             </a:r>
           </a:p>
         </p:txBody>
@@ -29320,7 +29662,7 @@
             <a:noAutofit/>
           </a:bodyPr>
           <a:lstStyle/>
-          <a:p>
+          <a:p xmlns:a="http://schemas.openxmlformats.org/drawingml/2006/main">
             <a:pPr algn="l">
               <a:spcBef>
                 <a:spcPts val="0"/>
@@ -29328,6 +29670,7 @@
               <a:spcAft>
                 <a:spcPts val="0"/>
               </a:spcAft>
+              <a:buNone/>
             </a:pPr>
             <a:r>
               <a:rPr sz="950" b="0" i="1">
@@ -29335,8 +29678,21 @@
                   <a:srgbClr val="5A6377"/>
                 </a:solidFill>
                 <a:latin typeface="Calibri"/>
-              </a:rPr>
-              <a:t>MVD pp. 13, 78, 84, 127, 156, 273, 300  ·  AVD p. 87  ·  KD p. 30  ·  AnalyticMadhyasthDarshan.org  ·  6 / 28</a:t>
+                <a:ea typeface="Calibri"/>
+                <a:cs typeface="Calibri"/>
+              </a:rPr>
+              <a:t>MVD pp. 13, 51, 78, 84, 156, 273, 300  ·  JV p. 121  ·  AVD p. 87</a:t>
+            </a:r>
+            <a:r>
+              <a:rPr sz="950" b="0" i="1">
+                <a:solidFill>
+                  <a:srgbClr val="5A6377"/>
+                </a:solidFill>
+                <a:latin typeface="Calibri"/>
+                <a:ea typeface="Calibri"/>
+                <a:cs typeface="Calibri"/>
+              </a:rPr>
+              <a:t>  ·  AnalyticMadhyasthDarshan.org  ·  6 / 28</a:t>
             </a:r>
           </a:p>
         </p:txBody>
@@ -29893,7 +30249,7 @@
             <a:noAutofit/>
           </a:bodyPr>
           <a:lstStyle/>
-          <a:p>
+          <a:p xmlns:a="http://schemas.openxmlformats.org/drawingml/2006/main">
             <a:pPr algn="l">
               <a:spcBef>
                 <a:spcPts val="0"/>
@@ -29901,6 +30257,7 @@
               <a:spcAft>
                 <a:spcPts val="0"/>
               </a:spcAft>
+              <a:buNone/>
             </a:pPr>
             <a:r>
               <a:rPr sz="1200" b="0" i="1">
@@ -29908,8 +30265,10 @@
                   <a:srgbClr val="1E2447"/>
                 </a:solidFill>
                 <a:latin typeface="Calibri"/>
-              </a:rPr>
-              <a:t>The awakened human is aware of their own being and of the being of the entire existence (MVD p. 84).</a:t>
+                <a:ea typeface="Calibri"/>
+                <a:cs typeface="Calibri"/>
+              </a:rPr>
+              <a:t>Dharma names innateness. Human dharma is continuous happiness, expressed in resolved thought and orderliness (MVD pp. 51, 156; JV p. 121).</a:t>
             </a:r>
           </a:p>
         </p:txBody>
@@ -30947,7 +31306,7 @@
             <a:noAutofit/>
           </a:bodyPr>
           <a:lstStyle/>
-          <a:p>
+          <a:p xmlns:a="http://schemas.openxmlformats.org/drawingml/2006/main">
             <a:pPr algn="l">
               <a:spcBef>
                 <a:spcPts val="0"/>
@@ -30955,6 +31314,7 @@
               <a:spcAft>
                 <a:spcPts val="0"/>
               </a:spcAft>
+              <a:buNone/>
             </a:pPr>
             <a:r>
               <a:rPr sz="1050" b="1" i="0">
@@ -30962,8 +31322,10 @@
                   <a:srgbClr val="9A6414"/>
                 </a:solidFill>
                 <a:latin typeface="Calibri"/>
-              </a:rPr>
-              <a:t>PART ONE  ·  §1.11  ·  THE LADDER OF REALISATION</a:t>
+                <a:ea typeface="Calibri"/>
+                <a:cs typeface="Calibri"/>
+              </a:rPr>
+              <a:t>PART ONE  ·  §1.11  ·  STUDY AND REALISATION</a:t>
             </a:r>
           </a:p>
         </p:txBody>
@@ -30989,7 +31351,7 @@
             <a:noAutofit/>
           </a:bodyPr>
           <a:lstStyle/>
-          <a:p>
+          <a:p xmlns:a="http://schemas.openxmlformats.org/drawingml/2006/main">
             <a:pPr algn="l">
               <a:spcBef>
                 <a:spcPts val="0"/>
@@ -30997,6 +31359,7 @@
               <a:spcAft>
                 <a:spcPts val="0"/>
               </a:spcAft>
+              <a:buNone/>
             </a:pPr>
             <a:r>
               <a:rPr sz="3000" b="1" i="0">
@@ -31004,8 +31367,10 @@
                   <a:srgbClr val="1E2447"/>
                 </a:solidFill>
                 <a:latin typeface="Cambria"/>
-              </a:rPr>
-              <a:t>Four Stages of One Process</a:t>
+                <a:ea typeface="Cambria"/>
+                <a:cs typeface="Cambria"/>
+              </a:rPr>
+              <a:t>Study and Realisation</a:t>
             </a:r>
           </a:p>
         </p:txBody>
@@ -31031,7 +31396,7 @@
             <a:noAutofit/>
           </a:bodyPr>
           <a:lstStyle/>
-          <a:p>
+          <a:p xmlns:a="http://schemas.openxmlformats.org/drawingml/2006/main">
             <a:pPr algn="l">
               <a:spcBef>
                 <a:spcPts val="0"/>
@@ -31039,6 +31404,7 @@
               <a:spcAft>
                 <a:spcPts val="0"/>
               </a:spcAft>
+              <a:buNone/>
             </a:pPr>
             <a:r>
               <a:rPr sz="950" b="0" i="1">
@@ -31046,8 +31412,21 @@
                   <a:srgbClr val="5A6377"/>
                 </a:solidFill>
                 <a:latin typeface="Calibri"/>
-              </a:rPr>
-              <a:t>MVD pp. 12, 33, 99, 126  ·  JV p. 62  ·  AVD p. 224  ·  AnalyticMadhyasthDarshan.org  ·  8 / 28</a:t>
+                <a:ea typeface="Calibri"/>
+                <a:cs typeface="Calibri"/>
+              </a:rPr>
+              <a:t>MVD pp. 12, 126, 207, 257, 295  ·  JV p. 62  ·  AVD p. 224</a:t>
+            </a:r>
+            <a:r>
+              <a:rPr sz="950" b="0" i="1">
+                <a:solidFill>
+                  <a:srgbClr val="5A6377"/>
+                </a:solidFill>
+                <a:latin typeface="Calibri"/>
+                <a:ea typeface="Calibri"/>
+                <a:cs typeface="Calibri"/>
+              </a:rPr>
+              <a:t>  ·  AnalyticMadhyasthDarshan.org  ·  8 / 28</a:t>
             </a:r>
           </a:p>
         </p:txBody>
@@ -31073,7 +31452,7 @@
             <a:noAutofit/>
           </a:bodyPr>
           <a:lstStyle/>
-          <a:p>
+          <a:p xmlns:a="http://schemas.openxmlformats.org/drawingml/2006/main">
             <a:pPr algn="l">
               <a:spcBef>
                 <a:spcPts val="0"/>
@@ -31081,6 +31460,7 @@
               <a:spcAft>
                 <a:spcPts val="0"/>
               </a:spcAft>
+              <a:buNone/>
             </a:pPr>
             <a:r>
               <a:rPr sz="950" b="1" i="0">
@@ -31088,8 +31468,10 @@
                   <a:srgbClr val="5A6377"/>
                 </a:solidFill>
                 <a:latin typeface="Calibri"/>
-              </a:rPr>
-              <a:t>PREPARATION</a:t>
+                <a:ea typeface="Calibri"/>
+                <a:cs typeface="Calibri"/>
+              </a:rPr>
+              <a:t>STUDY FUNCTIONS</a:t>
             </a:r>
           </a:p>
         </p:txBody>
@@ -31115,7 +31497,7 @@
             <a:noAutofit/>
           </a:bodyPr>
           <a:lstStyle/>
-          <a:p>
+          <a:p xmlns:a="http://schemas.openxmlformats.org/drawingml/2006/main">
             <a:pPr algn="l">
               <a:spcBef>
                 <a:spcPts val="0"/>
@@ -31123,6 +31505,7 @@
               <a:spcAft>
                 <a:spcPts val="0"/>
               </a:spcAft>
+              <a:buNone/>
             </a:pPr>
             <a:r>
               <a:rPr sz="950" b="1" i="0">
@@ -31130,8 +31513,10 @@
                   <a:srgbClr val="9A6414"/>
                 </a:solidFill>
                 <a:latin typeface="Calibri"/>
-              </a:rPr>
-              <a:t>THE FOUR STAGES</a:t>
+                <a:ea typeface="Calibri"/>
+                <a:cs typeface="Calibri"/>
+              </a:rPr>
+              <a:t>RECOGNITION TO EVIDENCE</a:t>
             </a:r>
           </a:p>
         </p:txBody>
@@ -31249,7 +31634,7 @@
             <a:noAutofit/>
           </a:bodyPr>
           <a:lstStyle/>
-          <a:p>
+          <a:p xmlns:a="http://schemas.openxmlformats.org/drawingml/2006/main">
             <a:pPr algn="ctr">
               <a:spcBef>
                 <a:spcPts val="0"/>
@@ -31257,6 +31642,7 @@
               <a:spcAft>
                 <a:spcPts val="0"/>
               </a:spcAft>
+              <a:buNone/>
             </a:pPr>
             <a:r>
               <a:rPr sz="1000" b="0" i="0">
@@ -31264,8 +31650,10 @@
                   <a:srgbClr val="5A6377"/>
                 </a:solidFill>
                 <a:latin typeface="Calibri"/>
-              </a:rPr>
-              <a:t>ratiocination</a:t>
+                <a:ea typeface="Calibri"/>
+                <a:cs typeface="Calibri"/>
+              </a:rPr>
+              <a:t>acceptance</a:t>
             </a:r>
           </a:p>
         </p:txBody>
@@ -31291,7 +31679,7 @@
             <a:noAutofit/>
           </a:bodyPr>
           <a:lstStyle/>
-          <a:p>
+          <a:p xmlns:a="http://schemas.openxmlformats.org/drawingml/2006/main">
             <a:pPr algn="ctr">
               <a:spcBef>
                 <a:spcPts val="0"/>
@@ -31299,6 +31687,7 @@
               <a:spcAft>
                 <a:spcPts val="0"/>
               </a:spcAft>
+              <a:buNone/>
             </a:pPr>
             <a:r>
               <a:rPr sz="1400" b="1" i="0">
@@ -31306,8 +31695,10 @@
                   <a:srgbClr val="C9821E"/>
                 </a:solidFill>
                 <a:latin typeface="Calibri"/>
-              </a:rPr>
-              <a:t>→</a:t>
+                <a:ea typeface="Calibri"/>
+                <a:cs typeface="Calibri"/>
+              </a:rPr>
+              <a:t> </a:t>
             </a:r>
           </a:p>
         </p:txBody>
@@ -31425,7 +31816,7 @@
             <a:noAutofit/>
           </a:bodyPr>
           <a:lstStyle/>
-          <a:p>
+          <a:p xmlns:a="http://schemas.openxmlformats.org/drawingml/2006/main">
             <a:pPr algn="ctr">
               <a:spcBef>
                 <a:spcPts val="0"/>
@@ -31433,6 +31824,7 @@
               <a:spcAft>
                 <a:spcPts val="0"/>
               </a:spcAft>
+              <a:buNone/>
             </a:pPr>
             <a:r>
               <a:rPr sz="1000" b="0" i="0">
@@ -31440,8 +31832,10 @@
                   <a:srgbClr val="5A6377"/>
                 </a:solidFill>
                 <a:latin typeface="Calibri"/>
-              </a:rPr>
-              <a:t>deliberation</a:t>
+                <a:ea typeface="Calibri"/>
+                <a:cs typeface="Calibri"/>
+              </a:rPr>
+              <a:t>qualitative deliberation</a:t>
             </a:r>
           </a:p>
         </p:txBody>
@@ -31467,7 +31861,7 @@
             <a:noAutofit/>
           </a:bodyPr>
           <a:lstStyle/>
-          <a:p>
+          <a:p xmlns:a="http://schemas.openxmlformats.org/drawingml/2006/main">
             <a:pPr algn="ctr">
               <a:spcBef>
                 <a:spcPts val="0"/>
@@ -31475,6 +31869,7 @@
               <a:spcAft>
                 <a:spcPts val="0"/>
               </a:spcAft>
+              <a:buNone/>
             </a:pPr>
             <a:r>
               <a:rPr sz="1400" b="1" i="0">
@@ -31482,8 +31877,10 @@
                   <a:srgbClr val="C9821E"/>
                 </a:solidFill>
                 <a:latin typeface="Calibri"/>
-              </a:rPr>
-              <a:t>→</a:t>
+                <a:ea typeface="Calibri"/>
+                <a:cs typeface="Calibri"/>
+              </a:rPr>
+              <a:t> </a:t>
             </a:r>
           </a:p>
         </p:txBody>
@@ -31819,7 +32216,7 @@
             <a:noAutofit/>
           </a:bodyPr>
           <a:lstStyle/>
-          <a:p>
+          <a:p xmlns:a="http://schemas.openxmlformats.org/drawingml/2006/main">
             <a:pPr algn="ctr">
               <a:spcBef>
                 <a:spcPts val="0"/>
@@ -31827,6 +32224,7 @@
               <a:spcAft>
                 <a:spcPts val="0"/>
               </a:spcAft>
+              <a:buNone/>
             </a:pPr>
             <a:r>
               <a:rPr sz="1400" b="1" i="0">
@@ -31834,8 +32232,10 @@
                   <a:srgbClr val="C9821E"/>
                 </a:solidFill>
                 <a:latin typeface="Calibri"/>
-              </a:rPr>
-              <a:t>→</a:t>
+                <a:ea typeface="Calibri"/>
+                <a:cs typeface="Calibri"/>
+              </a:rPr>
+              <a:t> </a:t>
             </a:r>
           </a:p>
         </p:txBody>
@@ -32202,7 +32602,7 @@
             <a:noAutofit/>
           </a:bodyPr>
           <a:lstStyle/>
-          <a:p>
+          <a:p xmlns:a="http://schemas.openxmlformats.org/drawingml/2006/main">
             <a:pPr algn="l">
               <a:spcBef>
                 <a:spcPts val="0"/>
@@ -32210,6 +32610,7 @@
               <a:spcAft>
                 <a:spcPts val="0"/>
               </a:spcAft>
+              <a:buNone/>
             </a:pPr>
             <a:r>
               <a:rPr sz="1250" b="1" i="0">
@@ -32217,8 +32618,10 @@
                   <a:srgbClr val="1E2447"/>
                 </a:solidFill>
                 <a:latin typeface="Cambria"/>
-              </a:rPr>
-              <a:t>Study reaches atma through the faculties</a:t>
+                <a:ea typeface="Cambria"/>
+                <a:cs typeface="Cambria"/>
+              </a:rPr>
+              <a:t>Teacher-guided study</a:t>
             </a:r>
           </a:p>
         </p:txBody>
@@ -32244,7 +32647,7 @@
             <a:noAutofit/>
           </a:bodyPr>
           <a:lstStyle/>
-          <a:p>
+          <a:p xmlns:a="http://schemas.openxmlformats.org/drawingml/2006/main">
             <a:pPr algn="l">
               <a:spcBef>
                 <a:spcPts val="0"/>
@@ -32252,6 +32655,7 @@
               <a:spcAft>
                 <a:spcPts val="0"/>
               </a:spcAft>
+              <a:buNone/>
             </a:pPr>
             <a:r>
               <a:rPr sz="1200" b="0" i="0">
@@ -32259,152 +32663,10 @@
                   <a:srgbClr val="5A6377"/>
                 </a:solidFill>
                 <a:latin typeface="Calibri"/>
-              </a:rPr>
-              <a:t>Affirming coexistence through study is </a:t>
-            </a:r>
-            <a:r>
-              <a:rPr sz="1200" b="0" i="1">
-                <a:solidFill>
-                  <a:srgbClr val="5A6377"/>
-                </a:solidFill>
-                <a:latin typeface="Calibri"/>
-              </a:rPr>
-              <a:t>manan</a:t>
-            </a:r>
-            <a:r>
-              <a:rPr sz="1200" b="0" i="0">
-                <a:solidFill>
-                  <a:srgbClr val="5A6377"/>
-                </a:solidFill>
-                <a:latin typeface="Calibri"/>
-              </a:rPr>
-              <a:t> in </a:t>
-            </a:r>
-            <a:r>
-              <a:rPr sz="1200" b="0" i="1">
-                <a:solidFill>
-                  <a:srgbClr val="5A6377"/>
-                </a:solidFill>
-                <a:latin typeface="Calibri"/>
-              </a:rPr>
-              <a:t>mun</a:t>
-            </a:r>
-            <a:r>
-              <a:rPr sz="1200" b="0" i="0">
-                <a:solidFill>
-                  <a:srgbClr val="5A6377"/>
-                </a:solidFill>
-                <a:latin typeface="Calibri"/>
-              </a:rPr>
-              <a:t>, </a:t>
-            </a:r>
-            <a:r>
-              <a:rPr sz="1200" b="0" i="1">
-                <a:solidFill>
-                  <a:srgbClr val="5A6377"/>
-                </a:solidFill>
-                <a:latin typeface="Calibri"/>
-              </a:rPr>
-              <a:t>tulan</a:t>
-            </a:r>
-            <a:r>
-              <a:rPr sz="1200" b="0" i="0">
-                <a:solidFill>
-                  <a:srgbClr val="5A6377"/>
-                </a:solidFill>
-                <a:latin typeface="Calibri"/>
-              </a:rPr>
-              <a:t> in </a:t>
-            </a:r>
-            <a:r>
-              <a:rPr sz="1200" b="0" i="1">
-                <a:solidFill>
-                  <a:srgbClr val="5A6377"/>
-                </a:solidFill>
-                <a:latin typeface="Calibri"/>
-              </a:rPr>
-              <a:t>vritti</a:t>
-            </a:r>
-            <a:r>
-              <a:rPr sz="1200" b="0" i="0">
-                <a:solidFill>
-                  <a:srgbClr val="5A6377"/>
-                </a:solidFill>
-                <a:latin typeface="Calibri"/>
-              </a:rPr>
-              <a:t>, </a:t>
-            </a:r>
-            <a:r>
-              <a:rPr sz="1200" b="0" i="1">
-                <a:solidFill>
-                  <a:srgbClr val="5A6377"/>
-                </a:solidFill>
-                <a:latin typeface="Calibri"/>
-              </a:rPr>
-              <a:t>sakshatkar</a:t>
-            </a:r>
-            <a:r>
-              <a:rPr sz="1200" b="0" i="0">
-                <a:solidFill>
-                  <a:srgbClr val="5A6377"/>
-                </a:solidFill>
-                <a:latin typeface="Calibri"/>
-              </a:rPr>
-              <a:t> in </a:t>
-            </a:r>
-            <a:r>
-              <a:rPr sz="1200" b="0" i="1">
-                <a:solidFill>
-                  <a:srgbClr val="5A6377"/>
-                </a:solidFill>
-                <a:latin typeface="Calibri"/>
-              </a:rPr>
-              <a:t>chitta</a:t>
-            </a:r>
-            <a:r>
-              <a:rPr sz="1200" b="0" i="0">
-                <a:solidFill>
-                  <a:srgbClr val="5A6377"/>
-                </a:solidFill>
-                <a:latin typeface="Calibri"/>
-              </a:rPr>
-              <a:t>, and </a:t>
-            </a:r>
-            <a:r>
-              <a:rPr sz="1200" b="0" i="1">
-                <a:solidFill>
-                  <a:srgbClr val="5A6377"/>
-                </a:solidFill>
-                <a:latin typeface="Calibri"/>
-              </a:rPr>
-              <a:t>bodh</a:t>
-            </a:r>
-            <a:r>
-              <a:rPr sz="1200" b="0" i="0">
-                <a:solidFill>
-                  <a:srgbClr val="5A6377"/>
-                </a:solidFill>
-                <a:latin typeface="Calibri"/>
-              </a:rPr>
-              <a:t> in </a:t>
-            </a:r>
-            <a:r>
-              <a:rPr sz="1200" b="0" i="1">
-                <a:solidFill>
-                  <a:srgbClr val="5A6377"/>
-                </a:solidFill>
-                <a:latin typeface="Calibri"/>
-              </a:rPr>
-              <a:t>buddhi</a:t>
-            </a:r>
-            <a:r>
-              <a:rPr sz="1200" b="0" i="0">
-                <a:solidFill>
-                  <a:srgbClr val="5A6377"/>
-                </a:solidFill>
-                <a:latin typeface="Calibri"/>
-              </a:rPr>
-              <a:t> (MVD p. 126).</a:t>
+                <a:ea typeface="Calibri"/>
+                <a:cs typeface="Calibri"/>
+              </a:rPr>
+              <a:t>Shravan, manan, arth-bodh: listening, reflection, and understanding meaning (MVD p. 257).</a:t>
             </a:r>
           </a:p>
         </p:txBody>
@@ -32461,7 +32723,7 @@
             <a:noAutofit/>
           </a:bodyPr>
           <a:lstStyle/>
-          <a:p>
+          <a:p xmlns:a="http://schemas.openxmlformats.org/drawingml/2006/main">
             <a:pPr algn="l">
               <a:spcBef>
                 <a:spcPts val="0"/>
@@ -32469,6 +32731,7 @@
               <a:spcAft>
                 <a:spcPts val="0"/>
               </a:spcAft>
+              <a:buNone/>
             </a:pPr>
             <a:r>
               <a:rPr sz="1250" b="1" i="0">
@@ -32476,8 +32739,10 @@
                   <a:srgbClr val="9A6414"/>
                 </a:solidFill>
                 <a:latin typeface="Cambria"/>
-              </a:rPr>
-              <a:t>Evidence completes the process</a:t>
+                <a:ea typeface="Cambria"/>
+                <a:cs typeface="Cambria"/>
+              </a:rPr>
+              <a:t>Completion and evidence</a:t>
             </a:r>
           </a:p>
         </p:txBody>
@@ -32503,7 +32768,7 @@
             <a:noAutofit/>
           </a:bodyPr>
           <a:lstStyle/>
-          <a:p>
+          <a:p xmlns:a="http://schemas.openxmlformats.org/drawingml/2006/main">
             <a:pPr algn="l">
               <a:spcBef>
                 <a:spcPts val="0"/>
@@ -32511,6 +32776,7 @@
               <a:spcAft>
                 <a:spcPts val="0"/>
               </a:spcAft>
+              <a:buNone/>
             </a:pPr>
             <a:r>
               <a:rPr sz="1200" b="0" i="0">
@@ -32518,8 +32784,10 @@
                   <a:srgbClr val="5A6377"/>
                 </a:solidFill>
                 <a:latin typeface="Calibri"/>
-              </a:rPr>
-              <a:t>What is realised can be stated, taught, and lived. Evidence is awakened tradition (MVD p. 12).</a:t>
+                <a:ea typeface="Calibri"/>
+                <a:cs typeface="Calibri"/>
+              </a:rPr>
+              <a:t>Complete bodh and anubhav become effective together (MVD p. 207). Understanding appears in living and tradition (MVD p. 12).</a:t>
             </a:r>
           </a:p>
         </p:txBody>
@@ -32545,7 +32813,7 @@
             <a:noAutofit/>
           </a:bodyPr>
           <a:lstStyle/>
-          <a:p>
+          <a:p xmlns:a="http://schemas.openxmlformats.org/drawingml/2006/main">
             <a:pPr algn="l">
               <a:spcBef>
                 <a:spcPts val="0"/>
@@ -32553,6 +32821,7 @@
               <a:spcAft>
                 <a:spcPts val="0"/>
               </a:spcAft>
+              <a:buNone/>
             </a:pPr>
             <a:r>
               <a:rPr sz="1200" b="0" i="1">
@@ -32560,8 +32829,10 @@
                   <a:srgbClr val="1E2447"/>
                 </a:solidFill>
                 <a:latin typeface="Calibri"/>
-              </a:rPr>
-              <a:t>Realisation adds no new object: it is where definitive understanding comes to rest (AVD p. 224).</a:t>
+                <a:ea typeface="Calibri"/>
+                <a:cs typeface="Calibri"/>
+              </a:rPr>
+              <a:t>Affirmation through study: manan in mun, tulan in vritti, sakshatkar in chitta, bodh in buddhi (MVD p. 126).</a:t>
             </a:r>
           </a:p>
         </p:txBody>

</xml_diff>

<commit_message>
Integrate Gupta's account of shravan manan and nididhyasan
</commit_message>
<xml_diff>
--- a/Studies/Spiritual-Practice-And-Realization/Spiritual-Practice-And-Realization-Madhyasth-Darshan.pptx
+++ b/Studies/Spiritual-Practice-And-Realization/Spiritual-Practice-And-Realization-Madhyasth-Darshan.pptx
@@ -1810,6 +1810,16 @@
               <a:t>Yog is redefined too. It is union — not posture or breath — and the realisation of the self is attained through yog in the tradition: the union of body and jeevan, and union with awakened humans for awakening. That is why humans seek association with those more awakened than themselves. The practice vocabulary is kept, and each term is given a content defined by understanding and conduct.</a:t>
             </a:r>
           </a:p>
+          <a:p xmlns:a="http://schemas.openxmlformats.org/drawingml/2006/main">
+            <a:r>
+              <a:t/>
+            </a:r>
+          </a:p>
+          <a:p xmlns:a="http://schemas.openxmlformats.org/drawingml/2006/main">
+            <a:r>
+              <a:t>The shravan–manan–nididhyasan triad also has a positive teaching meaning here. Rakesh Gupta's explanation, supplied on September 27, 2026, presents nididhyasan as the unfolding of direct cognition, conception in buddhi with resolve, and thereafter realisation in atma. Slide 8 presents this interpretation alongside the primary-text account of complete understanding and realisation becoming effective together.</a:t>
+            </a:r>
+          </a:p>
         </p:txBody>
       </p:sp>
       <p:sp>
@@ -2885,7 +2895,7 @@
           <a:lstStyle xmlns:a="http://schemas.openxmlformats.org/drawingml/2006/main"/>
           <a:p xmlns:a="http://schemas.openxmlformats.org/drawingml/2006/main">
             <a:r>
-              <a:t>Teacher-guided study involves shravan, manan, and arth-bodh: listening, reflection, and understanding meaning (MVD p. 257). Listening gives the learner an entry into study. Reflection and understanding continue as the meaning becomes clear.</a:t>
+              <a:t>This slide follows Rakesh Gupta's explanation, supplied on September 27, 2026, of shravan, manan, and nididhyasan in Madhyasth Darshan. It is attributed interpretation, rather than a quotation from Nagraj.</a:t>
             </a:r>
           </a:p>
           <a:p xmlns:a="http://schemas.openxmlformats.org/drawingml/2006/main">
@@ -2895,7 +2905,7 @@
           </a:p>
           <a:p xmlns:a="http://schemas.openxmlformats.org/drawingml/2006/main">
             <a:r>
-              <a:t>Affirmation of coexistence through study is named manan in mun, tulan in vritti, sakshatkar in chitta, and bodh in buddhi. Here manan concerns acceptance and tulan qualitative deliberation (MVD p. 126). These are related faculty functions. They do not prescribe separate periods in which one must finish before the next starts. The full development of mun also involves reflection upon the justice-based thoughts of vritti (MVD p. 295).</a:t>
+              <a:t>Shravan is listening with the intention of understanding the meaning. Manan is ratiocination: drawing together different threads of listening into a coherent view and reaching a logical conclusion about reality and how to live. It is accompanied by practice in living. Shravan and manan overlap; listening, reasoning, and practice enrich one another.</a:t>
             </a:r>
           </a:p>
           <a:p xmlns:a="http://schemas.openxmlformats.org/drawingml/2006/main">
@@ -2905,7 +2915,7 @@
           </a:p>
           <a:p xmlns:a="http://schemas.openxmlformats.org/drawingml/2006/main">
             <a:r>
-              <a:t>Direct recognition, understanding, realisation, and evidence distinguish connected aspects of accomplishment and expression. Nagraj describes sakshatkar, definitive understanding, and realisation in that order in his own case (JV p. 62). Complete bodh in buddhi coincides with anubhav in atma (MVD p. 207). Atma-bodh and realisation in coexistence become effective together (MVD pp. 286–287).</a:t>
+              <a:t>Nididhyasan is the unfolding of direct cognition, sakshatkar, conception in buddhi together with resolve, and thereafter realisation in atma. The resulting establishment in understanding and realisation of coexistence becomes indelible sanskar in jeevan. This is the fulfilled establishment being described, rather than every provisional conception or formation. The diagram's nididhyasan heading covers direct cognition, conception with resolve, and realisation. Praman is shown separately as expression and evidence in living.</a:t>
             </a:r>
           </a:p>
           <a:p xmlns:a="http://schemas.openxmlformats.org/drawingml/2006/main">
@@ -2915,7 +2925,7 @@
           </a:p>
           <a:p xmlns:a="http://schemas.openxmlformats.org/drawingml/2006/main">
             <a:r>
-              <a:t>Realisation is the ultimate evidence. Understanding manifests in resolution, work, and behaviour, and evidence is awakened tradition (MVD p. 12). What is understood can be communicated and lived. The diagram distinguishes these relationships without imposing a waiting period between complete understanding and realisation.</a:t>
+              <a:t>The primary text describes complete bodh in buddhi and anubhav in atma becoming effective together (MVD p. 207; see also pp. 286–287). Gupta's ordered account explains the unfolding towards this completion. Nagraj also recounts direct recognition, definitive understanding, and realisation in that order in his own case (JV p. 62). Practice and study cultivate sanskar (MVD p. 187); conceptions in buddhi express themselves through thought and action, while action returns through inference to conception and sanskar (MVD p. 218).</a:t>
             </a:r>
           </a:p>
           <a:p xmlns:a="http://schemas.openxmlformats.org/drawingml/2006/main">
@@ -2925,7 +2935,17 @@
           </a:p>
           <a:p xmlns:a="http://schemas.openxmlformats.org/drawingml/2006/main">
             <a:r>
-              <a:t>Shravan means listening. It is distinct from shruti, realised articulation or communication of understanding (MVD pp. 324, 329). Focused attention for understanding and evidence is dhyan (MVD pp. 284–285).</a:t>
+              <a:t>Teaching-method manan here means ratiocination. The narrower faculty correspondence names affirmation of coexistence through study as manan in mun, tulan in vritti, sakshatkar in chitta, and bodh in buddhi (MVD p. 126). There, manan concerns acceptance and tulan qualitative deliberation. The development of mun also involves reflection upon justice-based thoughts of vritti (MVD p. 295). Teacher-guided study is elsewhere described through shravan, manan, and arth-bodh (MVD p. 257).</a:t>
+            </a:r>
+          </a:p>
+          <a:p xmlns:a="http://schemas.openxmlformats.org/drawingml/2006/main">
+            <a:r>
+              <a:t/>
+            </a:r>
+          </a:p>
+          <a:p xmlns:a="http://schemas.openxmlformats.org/drawingml/2006/main">
+            <a:r>
+              <a:t>Realisation is the ultimate evidence. Understanding manifests in resolution, work, behaviour, and awakened tradition (MVD p. 12). Shravan, listening, is distinct from shruti, realised articulation or communication of understanding (MVD pp. 324, 329). Focused attention for understanding and evidence is dhyan (MVD pp. 284–285).</a:t>
             </a:r>
           </a:p>
         </p:txBody>
@@ -31415,7 +31435,7 @@
                 <a:ea typeface="Calibri"/>
                 <a:cs typeface="Calibri"/>
               </a:rPr>
-              <a:t>MVD pp. 12, 126, 207, 257, 295  ·  JV p. 62  ·  AVD p. 224</a:t>
+              <a:t>Rakesh Gupta, explanation supplied Sep 27, 2026  ·  MVD pp. 126, 207, 257</a:t>
             </a:r>
             <a:r>
               <a:rPr sz="950" b="0" i="1">
@@ -31471,7 +31491,7 @@
                 <a:ea typeface="Calibri"/>
                 <a:cs typeface="Calibri"/>
               </a:rPr>
-              <a:t>STUDY FUNCTIONS</a:t>
+              <a:t>SHRAVAN AND MANAN OVERLAP</a:t>
             </a:r>
           </a:p>
         </p:txBody>
@@ -31516,7 +31536,7 @@
                 <a:ea typeface="Calibri"/>
                 <a:cs typeface="Calibri"/>
               </a:rPr>
-              <a:t>RECOGNITION TO EVIDENCE</a:t>
+              <a:t>NIDIDHYASAN</a:t>
             </a:r>
           </a:p>
         </p:txBody>
@@ -31573,7 +31593,7 @@
             <a:noAutofit/>
           </a:bodyPr>
           <a:lstStyle/>
-          <a:p>
+          <a:p xmlns:a="http://schemas.openxmlformats.org/drawingml/2006/main">
             <a:pPr algn="ctr">
               <a:spcBef>
                 <a:spcPts val="0"/>
@@ -31581,6 +31601,7 @@
               <a:spcAft>
                 <a:spcPts val="0"/>
               </a:spcAft>
+              <a:buNone/>
             </a:pPr>
             <a:r>
               <a:rPr sz="1250" b="1" i="0">
@@ -31588,11 +31609,13 @@
                   <a:srgbClr val="1E2447"/>
                 </a:solidFill>
                 <a:latin typeface="Cambria"/>
-              </a:rPr>
-              <a:t>Manan</a:t>
-            </a:r>
-          </a:p>
-          <a:p>
+                <a:ea typeface="Cambria"/>
+                <a:cs typeface="Cambria"/>
+              </a:rPr>
+              <a:t>Shravan</a:t>
+            </a:r>
+          </a:p>
+          <a:p xmlns:a="http://schemas.openxmlformats.org/drawingml/2006/main">
             <a:pPr algn="ctr">
               <a:spcBef>
                 <a:spcPts val="0"/>
@@ -31600,6 +31623,7 @@
               <a:spcAft>
                 <a:spcPts val="0"/>
               </a:spcAft>
+              <a:buNone/>
             </a:pPr>
             <a:r>
               <a:rPr sz="1000" b="0" i="1">
@@ -31607,8 +31631,10 @@
                   <a:srgbClr val="5A6377"/>
                 </a:solidFill>
                 <a:latin typeface="Calibri"/>
-              </a:rPr>
-              <a:t>in mun</a:t>
+                <a:ea typeface="Calibri"/>
+                <a:cs typeface="Calibri"/>
+              </a:rPr>
+              <a:t>listening</a:t>
             </a:r>
           </a:p>
         </p:txBody>
@@ -31653,7 +31679,8 @@
                 <a:ea typeface="Calibri"/>
                 <a:cs typeface="Calibri"/>
               </a:rPr>
-              <a:t>acceptance</a:t>
+              <a:t>to understand
+meaning</a:t>
             </a:r>
           </a:p>
         </p:txBody>
@@ -31755,7 +31782,7 @@
             <a:noAutofit/>
           </a:bodyPr>
           <a:lstStyle/>
-          <a:p>
+          <a:p xmlns:a="http://schemas.openxmlformats.org/drawingml/2006/main">
             <a:pPr algn="ctr">
               <a:spcBef>
                 <a:spcPts val="0"/>
@@ -31763,6 +31790,7 @@
               <a:spcAft>
                 <a:spcPts val="0"/>
               </a:spcAft>
+              <a:buNone/>
             </a:pPr>
             <a:r>
               <a:rPr sz="1250" b="1" i="0">
@@ -31770,11 +31798,13 @@
                   <a:srgbClr val="1E2447"/>
                 </a:solidFill>
                 <a:latin typeface="Cambria"/>
-              </a:rPr>
-              <a:t>Tulan</a:t>
-            </a:r>
-          </a:p>
-          <a:p>
+                <a:ea typeface="Cambria"/>
+                <a:cs typeface="Cambria"/>
+              </a:rPr>
+              <a:t>Manan</a:t>
+            </a:r>
+          </a:p>
+          <a:p xmlns:a="http://schemas.openxmlformats.org/drawingml/2006/main">
             <a:pPr algn="ctr">
               <a:spcBef>
                 <a:spcPts val="0"/>
@@ -31782,6 +31812,7 @@
               <a:spcAft>
                 <a:spcPts val="0"/>
               </a:spcAft>
+              <a:buNone/>
             </a:pPr>
             <a:r>
               <a:rPr sz="1000" b="0" i="1">
@@ -31789,8 +31820,10 @@
                   <a:srgbClr val="5A6377"/>
                 </a:solidFill>
                 <a:latin typeface="Calibri"/>
-              </a:rPr>
-              <a:t>in vritti</a:t>
+                <a:ea typeface="Calibri"/>
+                <a:cs typeface="Calibri"/>
+              </a:rPr>
+              <a:t>ratiocination</a:t>
             </a:r>
           </a:p>
         </p:txBody>
@@ -31835,7 +31868,8 @@
                 <a:ea typeface="Calibri"/>
                 <a:cs typeface="Calibri"/>
               </a:rPr>
-              <a:t>qualitative deliberation</a:t>
+              <a:t>coherent view;
+logical conclusion</a:t>
             </a:r>
           </a:p>
         </p:txBody>
@@ -31998,7 +32032,7 @@
             <a:noAutofit/>
           </a:bodyPr>
           <a:lstStyle/>
-          <a:p>
+          <a:p xmlns:a="http://schemas.openxmlformats.org/drawingml/2006/main">
             <a:pPr algn="ctr">
               <a:spcBef>
                 <a:spcPts val="0"/>
@@ -32006,6 +32040,7 @@
               <a:spcAft>
                 <a:spcPts val="0"/>
               </a:spcAft>
+              <a:buNone/>
             </a:pPr>
             <a:r>
               <a:rPr sz="1000" b="0" i="0">
@@ -32013,8 +32048,10 @@
                   <a:srgbClr val="5A6377"/>
                 </a:solidFill>
                 <a:latin typeface="Calibri"/>
-              </a:rPr>
-              <a:t>direct recognition</a:t>
+                <a:ea typeface="Calibri"/>
+                <a:cs typeface="Calibri"/>
+              </a:rPr>
+              <a:t>direct cognition</a:t>
             </a:r>
           </a:p>
         </p:txBody>
@@ -32113,7 +32150,7 @@
             <a:noAutofit/>
           </a:bodyPr>
           <a:lstStyle/>
-          <a:p>
+          <a:p xmlns:a="http://schemas.openxmlformats.org/drawingml/2006/main">
             <a:pPr algn="ctr">
               <a:spcBef>
                 <a:spcPts val="0"/>
@@ -32121,6 +32158,7 @@
               <a:spcAft>
                 <a:spcPts val="0"/>
               </a:spcAft>
+              <a:buNone/>
             </a:pPr>
             <a:r>
               <a:rPr sz="1250" b="1" i="0">
@@ -32128,11 +32166,13 @@
                   <a:srgbClr val="FFFFFF"/>
                 </a:solidFill>
                 <a:latin typeface="Cambria"/>
-              </a:rPr>
-              <a:t>Bodh</a:t>
-            </a:r>
-          </a:p>
-          <a:p>
+                <a:ea typeface="Cambria"/>
+                <a:cs typeface="Cambria"/>
+              </a:rPr>
+              <a:t>Conception</a:t>
+            </a:r>
+          </a:p>
+          <a:p xmlns:a="http://schemas.openxmlformats.org/drawingml/2006/main">
             <a:pPr algn="ctr">
               <a:spcBef>
                 <a:spcPts val="0"/>
@@ -32140,6 +32180,7 @@
               <a:spcAft>
                 <a:spcPts val="0"/>
               </a:spcAft>
+              <a:buNone/>
             </a:pPr>
             <a:r>
               <a:rPr sz="1000" b="0" i="1">
@@ -32147,6 +32188,8 @@
                   <a:srgbClr val="C9D4EF"/>
                 </a:solidFill>
                 <a:latin typeface="Calibri"/>
+                <a:ea typeface="Calibri"/>
+                <a:cs typeface="Calibri"/>
               </a:rPr>
               <a:t>in buddhi</a:t>
             </a:r>
@@ -32174,7 +32217,7 @@
             <a:noAutofit/>
           </a:bodyPr>
           <a:lstStyle/>
-          <a:p>
+          <a:p xmlns:a="http://schemas.openxmlformats.org/drawingml/2006/main">
             <a:pPr algn="ctr">
               <a:spcBef>
                 <a:spcPts val="0"/>
@@ -32182,6 +32225,7 @@
               <a:spcAft>
                 <a:spcPts val="0"/>
               </a:spcAft>
+              <a:buNone/>
             </a:pPr>
             <a:r>
               <a:rPr sz="1000" b="0" i="0">
@@ -32189,8 +32233,10 @@
                   <a:srgbClr val="5A6377"/>
                 </a:solidFill>
                 <a:latin typeface="Calibri"/>
-              </a:rPr>
-              <a:t>enlightenment and acceptance</a:t>
+                <a:ea typeface="Calibri"/>
+                <a:cs typeface="Calibri"/>
+              </a:rPr>
+              <a:t>with resolve</a:t>
             </a:r>
           </a:p>
         </p:txBody>
@@ -32225,17 +32271,25 @@
                 <a:spcPts val="0"/>
               </a:spcAft>
               <a:buNone/>
-            </a:pPr>
-            <a:r>
-              <a:rPr sz="1400" b="1" i="0">
+              <a:defRPr sz="1400" b="1">
                 <a:solidFill>
                   <a:srgbClr val="C9821E"/>
                 </a:solidFill>
                 <a:latin typeface="Calibri"/>
                 <a:ea typeface="Calibri"/>
                 <a:cs typeface="Calibri"/>
-              </a:rPr>
-              <a:t> </a:t>
+              </a:defRPr>
+            </a:pPr>
+            <a:r>
+              <a:rPr sz="1400" b="1" i="0">
+                <a:solidFill>
+                  <a:srgbClr val="C9821E"/>
+                </a:solidFill>
+                <a:latin typeface="Calibri"/>
+                <a:ea typeface="Calibri"/>
+                <a:cs typeface="Calibri"/>
+              </a:rPr>
+              <a:t>→</a:t>
             </a:r>
           </a:p>
         </p:txBody>
@@ -32621,7 +32675,7 @@
                 <a:ea typeface="Cambria"/>
                 <a:cs typeface="Cambria"/>
               </a:rPr>
-              <a:t>Teacher-guided study</a:t>
+              <a:t>Ratiocination with practice</a:t>
             </a:r>
           </a:p>
         </p:txBody>
@@ -32666,7 +32720,7 @@
                 <a:ea typeface="Calibri"/>
                 <a:cs typeface="Calibri"/>
               </a:rPr>
-              <a:t>Shravan, manan, arth-bodh: listening, reflection, and understanding meaning (MVD p. 257).</a:t>
+              <a:t>Listening threads form a coherent view and a logical conclusion about reality and how to live, accompanied by practice in living.</a:t>
             </a:r>
           </a:p>
         </p:txBody>
@@ -32742,7 +32796,7 @@
                 <a:ea typeface="Cambria"/>
                 <a:cs typeface="Cambria"/>
               </a:rPr>
-              <a:t>Completion and evidence</a:t>
+              <a:t>Establishment as sanskar</a:t>
             </a:r>
           </a:p>
         </p:txBody>
@@ -32787,7 +32841,7 @@
                 <a:ea typeface="Calibri"/>
                 <a:cs typeface="Calibri"/>
               </a:rPr>
-              <a:t>Complete bodh and anubhav become effective together (MVD p. 207). Understanding appears in living and tradition (MVD p. 12).</a:t>
+              <a:t>Understanding and realisation of coexistence become indelible sanskar in jeevan. Complete bodh and anubhav become effective together (MVD p. 207).</a:t>
             </a:r>
           </a:p>
         </p:txBody>
@@ -32832,7 +32886,64 @@
                 <a:ea typeface="Calibri"/>
                 <a:cs typeface="Calibri"/>
               </a:rPr>
-              <a:t>Affirmation through study: manan in mun, tulan in vritti, sakshatkar in chitta, bodh in buddhi (MVD p. 126).</a:t>
+              <a:t>Faculty terms: manan/mun (acceptance), tulan/vritti, sakshatkar/chitta, bodh/buddhi (MVD p. 126).</a:t>
+            </a:r>
+          </a:p>
+        </p:txBody>
+      </p:sp>
+      <p:sp>
+        <p:nvSpPr>
+          <p:cNvPr id="40" name="TextBox 39">
+            <a:extLst xmlns:a="http://schemas.openxmlformats.org/drawingml/2006/main">
+              <a:ext uri="{FF2B5EF4-FFF2-40B4-BE49-F238E27FC236}">
+                <a16:creationId xmlns:a16="http://schemas.microsoft.com/office/drawing/2014/main" id="{03448647-D6E8-4D54-A30D-1E5180A7A461}"/>
+              </a:ext>
+            </a:extLst>
+          </p:cNvPr>
+          <p:cNvSpPr>
+            <a:spLocks xmlns:a="http://schemas.openxmlformats.org/drawingml/2006/main" noGrp="1"/>
+          </p:cNvSpPr>
+          <p:nvPr/>
+        </p:nvSpPr>
+        <p:spPr>
+          <a:xfrm xmlns:a="http://schemas.openxmlformats.org/drawingml/2006/main">
+            <a:off x="7383780" y="1097280"/>
+            <a:ext cx="1120140" cy="201168"/>
+          </a:xfrm>
+          <a:prstGeom xmlns:a="http://schemas.openxmlformats.org/drawingml/2006/main" prst="rect">
+            <a:avLst/>
+          </a:prstGeom>
+          <a:noFill xmlns:a="http://schemas.openxmlformats.org/drawingml/2006/main"/>
+          <a:ln xmlns:a="http://schemas.openxmlformats.org/drawingml/2006/main" w="0">
+            <a:noFill/>
+          </a:ln>
+        </p:spPr>
+        <p:txBody>
+          <a:bodyPr xmlns:a="http://schemas.openxmlformats.org/drawingml/2006/main" lIns="0" tIns="0" rIns="0" bIns="0" anchor="ctr">
+            <a:noAutofit/>
+          </a:bodyPr>
+          <a:lstStyle xmlns:a="http://schemas.openxmlformats.org/drawingml/2006/main"/>
+          <a:p xmlns:a="http://schemas.openxmlformats.org/drawingml/2006/main">
+            <a:pPr algn="l">
+              <a:defRPr sz="950" b="1">
+                <a:solidFill>
+                  <a:srgbClr val="9A6414"/>
+                </a:solidFill>
+                <a:latin typeface="Calibri"/>
+                <a:ea typeface="Calibri"/>
+                <a:cs typeface="Calibri"/>
+              </a:defRPr>
+            </a:pPr>
+            <a:r>
+              <a:rPr sz="950" b="1">
+                <a:solidFill>
+                  <a:srgbClr val="9A6414"/>
+                </a:solidFill>
+                <a:latin typeface="Calibri"/>
+                <a:ea typeface="Calibri"/>
+                <a:cs typeface="Calibri"/>
+              </a:rPr>
+              <a:t>EXPRESSION</a:t>
             </a:r>
           </a:p>
         </p:txBody>

</xml_diff>